<commit_message>
feat: add Testing/Evaluation + Limitations/Future Work slides (assistant feedback)
Addresses Muhammad Fayaz's review. Deck now 17 slides:
- Evaluation: test-case table (mood input → expected → actual → Pass) plus
  four edge-case cards (mixed mood, AI failure, empty input, gibberish)
- Limitations & Future Work: honest limitations vs. a 5-point roadmap
  (user profiles, feedback-based personalization, larger library,
  deployment + database, automated tests)

Both re-rendered and visually verified; fixed numbered-list rendering.

Co-Authored-By: Claude Sonnet 4.6 <noreply@anthropic.com>
</commit_message>
<xml_diff>
--- a/deliverables/CINEMATCH-Presentation.pptx
+++ b/deliverables/CINEMATCH-Presentation.pptx
@@ -20,9 +20,11 @@
     <p:sldId id="268" r:id="rId14"/>
     <p:sldId id="269" r:id="rId15"/>
     <p:sldId id="270" r:id="rId16"/>
+    <p:sldId id="271" r:id="rId17"/>
+    <p:sldId id="272" r:id="rId18"/>
   </p:sldIdLst>
   <p:notesMasterIdLst>
-    <p:notesMasterId r:id="rId17"/>
+    <p:notesMasterId r:id="rId19"/>
   </p:notesMasterIdLst>
   <p:sldSz cx="12192000" cy="6858000"/>
   <p:notesSz cx="6858000" cy="12192000"/>
@@ -1381,6 +1383,182 @@
             <a:fld id="{F7021451-1387-4CA6-816F-3879F97B5CBC}" type="slidenum">
               <a:rPr lang="en-US"/>
               <a:t>15</a:t>
+            </a:fld>
+            <a:endParaRPr lang="en-US"/>
+          </a:p>
+        </p:txBody>
+      </p:sp>
+    </p:spTree>
+    <p:extLst>
+      <p:ext uri="{BB962C8B-B14F-4D97-AF65-F5344CB8AC3E}">
+        <p14:creationId xmlns:p14="http://schemas.microsoft.com/office/powerpoint/2010/main" val="1024086991"/>
+      </p:ext>
+    </p:extLst>
+  </p:cSld>
+  <p:clrMapOvr>
+    <a:masterClrMapping/>
+  </p:clrMapOvr>
+</p:notes>
+</file>
+
+<file path=ppt/notesSlides/notesSlide16.xml><?xml version="1.0" encoding="utf-8"?>
+<p:notes xmlns:a="http://schemas.openxmlformats.org/drawingml/2006/main" xmlns:r="http://schemas.openxmlformats.org/officeDocument/2006/relationships" xmlns:p="http://schemas.openxmlformats.org/presentationml/2006/main">
+  <p:cSld>
+    <p:spTree>
+      <p:nvGrpSpPr>
+        <p:cNvPr id="1" name=""/>
+        <p:cNvGrpSpPr/>
+        <p:nvPr/>
+      </p:nvGrpSpPr>
+      <p:grpSpPr>
+        <a:xfrm>
+          <a:off x="0" y="0"/>
+          <a:ext cx="0" cy="0"/>
+          <a:chOff x="0" y="0"/>
+          <a:chExt cx="0" cy="0"/>
+        </a:xfrm>
+      </p:grpSpPr>
+      <p:sp>
+        <p:nvSpPr>
+          <p:cNvPr id="2" name="Slide Image Placeholder 1"/>
+          <p:cNvSpPr>
+            <a:spLocks noGrp="1" noRot="1" noChangeAspect="1"/>
+          </p:cNvSpPr>
+          <p:nvPr>
+            <p:ph type="sldImg"/>
+          </p:nvPr>
+        </p:nvSpPr>
+        <p:spPr/>
+      </p:sp>
+      <p:sp>
+        <p:nvSpPr>
+          <p:cNvPr id="3" name="Notes Placeholder 2"/>
+          <p:cNvSpPr>
+            <a:spLocks noGrp="1"/>
+          </p:cNvSpPr>
+          <p:nvPr>
+            <p:ph type="body" idx="1"/>
+          </p:nvPr>
+        </p:nvSpPr>
+        <p:spPr/>
+        <p:txBody>
+          <a:bodyPr/>
+          <a:lstStyle/>
+          <a:p>
+            <a:r>
+              <a:rPr lang="en-US" dirty="0"/>
+              <a:t/>
+            </a:r>
+            <a:endParaRPr lang="en-US" dirty="0"/>
+          </a:p>
+        </p:txBody>
+      </p:sp>
+      <p:sp>
+        <p:nvSpPr>
+          <p:cNvPr id="4" name="Slide Number Placeholder 3"/>
+          <p:cNvSpPr>
+            <a:spLocks noGrp="1"/>
+          </p:cNvSpPr>
+          <p:nvPr>
+            <p:ph type="sldNum" sz="quarter" idx="10"/>
+          </p:nvPr>
+        </p:nvSpPr>
+        <p:spPr/>
+        <p:txBody>
+          <a:bodyPr/>
+          <a:lstStyle/>
+          <a:p>
+            <a:fld id="{F7021451-1387-4CA6-816F-3879F97B5CBC}" type="slidenum">
+              <a:rPr lang="en-US"/>
+              <a:t>16</a:t>
+            </a:fld>
+            <a:endParaRPr lang="en-US"/>
+          </a:p>
+        </p:txBody>
+      </p:sp>
+    </p:spTree>
+    <p:extLst>
+      <p:ext uri="{BB962C8B-B14F-4D97-AF65-F5344CB8AC3E}">
+        <p14:creationId xmlns:p14="http://schemas.microsoft.com/office/powerpoint/2010/main" val="1024086991"/>
+      </p:ext>
+    </p:extLst>
+  </p:cSld>
+  <p:clrMapOvr>
+    <a:masterClrMapping/>
+  </p:clrMapOvr>
+</p:notes>
+</file>
+
+<file path=ppt/notesSlides/notesSlide17.xml><?xml version="1.0" encoding="utf-8"?>
+<p:notes xmlns:a="http://schemas.openxmlformats.org/drawingml/2006/main" xmlns:r="http://schemas.openxmlformats.org/officeDocument/2006/relationships" xmlns:p="http://schemas.openxmlformats.org/presentationml/2006/main">
+  <p:cSld>
+    <p:spTree>
+      <p:nvGrpSpPr>
+        <p:cNvPr id="1" name=""/>
+        <p:cNvGrpSpPr/>
+        <p:nvPr/>
+      </p:nvGrpSpPr>
+      <p:grpSpPr>
+        <a:xfrm>
+          <a:off x="0" y="0"/>
+          <a:ext cx="0" cy="0"/>
+          <a:chOff x="0" y="0"/>
+          <a:chExt cx="0" cy="0"/>
+        </a:xfrm>
+      </p:grpSpPr>
+      <p:sp>
+        <p:nvSpPr>
+          <p:cNvPr id="2" name="Slide Image Placeholder 1"/>
+          <p:cNvSpPr>
+            <a:spLocks noGrp="1" noRot="1" noChangeAspect="1"/>
+          </p:cNvSpPr>
+          <p:nvPr>
+            <p:ph type="sldImg"/>
+          </p:nvPr>
+        </p:nvSpPr>
+        <p:spPr/>
+      </p:sp>
+      <p:sp>
+        <p:nvSpPr>
+          <p:cNvPr id="3" name="Notes Placeholder 2"/>
+          <p:cNvSpPr>
+            <a:spLocks noGrp="1"/>
+          </p:cNvSpPr>
+          <p:nvPr>
+            <p:ph type="body" idx="1"/>
+          </p:nvPr>
+        </p:nvSpPr>
+        <p:spPr/>
+        <p:txBody>
+          <a:bodyPr/>
+          <a:lstStyle/>
+          <a:p>
+            <a:r>
+              <a:rPr lang="en-US" dirty="0"/>
+              <a:t/>
+            </a:r>
+            <a:endParaRPr lang="en-US" dirty="0"/>
+          </a:p>
+        </p:txBody>
+      </p:sp>
+      <p:sp>
+        <p:nvSpPr>
+          <p:cNvPr id="4" name="Slide Number Placeholder 3"/>
+          <p:cNvSpPr>
+            <a:spLocks noGrp="1"/>
+          </p:cNvSpPr>
+          <p:nvPr>
+            <p:ph type="sldNum" sz="quarter" idx="10"/>
+          </p:nvPr>
+        </p:nvSpPr>
+        <p:spPr/>
+        <p:txBody>
+          <a:bodyPr/>
+          <a:lstStyle/>
+          <a:p>
+            <a:fld id="{F7021451-1387-4CA6-816F-3879F97B5CBC}" type="slidenum">
+              <a:rPr lang="en-US"/>
+              <a:t>17</a:t>
             </a:fld>
             <a:endParaRPr lang="en-US"/>
           </a:p>
@@ -6648,7 +6826,7 @@
                 <a:ea typeface="Calibri" pitchFamily="34" charset="-122"/>
                 <a:cs typeface="Calibri" pitchFamily="34" charset="-120"/>
               </a:rPr>
-              <a:t>UNDER THE HOOD</a:t>
+              <a:t>EVALUATION</a:t>
             </a:r>
             <a:endParaRPr lang="en-US" sz="1200" dirty="0"/>
           </a:p>
@@ -6687,26 +6865,1467 @@
                 <a:ea typeface="Georgia" pitchFamily="34" charset="-122"/>
                 <a:cs typeface="Georgia" pitchFamily="34" charset="-120"/>
               </a:rPr>
-              <a:t>Tech stack &amp; open data</a:t>
+              <a:t>Testing the recommendation pipeline</a:t>
             </a:r>
             <a:endParaRPr lang="en-US" sz="3200" dirty="0"/>
           </a:p>
         </p:txBody>
       </p:sp>
-      <p:sp>
-        <p:nvSpPr>
-          <p:cNvPr id="5" name="Shape 3"/>
-          <p:cNvSpPr/>
-          <p:nvPr/>
-        </p:nvSpPr>
-        <p:spPr>
-          <a:xfrm>
-            <a:off x="640080" y="2103120"/>
-            <a:ext cx="2446020" cy="1554480"/>
+      <p:graphicFrame>
+        <p:nvGraphicFramePr>
+          <p:cNvPr id="15" name="Table 0"/>
+          <p:cNvGraphicFramePr>
+            <a:graphicFrameLocks noGrp="1"/>
+          </p:cNvGraphicFramePr>
+          <p:nvPr>
+            <p:extLst>
+              <p:ext uri="{D42A27DB-BD31-4B8C-83A1-F6EECF244321}">
+                <p14:modId xmlns:p14="http://schemas.microsoft.com/office/powerpoint/2010/main" val="1579011935"/>
+              </p:ext>
+            </p:extLst>
+          </p:nvPr>
+        </p:nvGraphicFramePr>
+        <p:xfrm>
+          <a:off x="640080" y="1737360"/>
+          <a:ext cx="10881360" cy="914400"/>
+        </p:xfrm>
+        <a:graphic>
+          <a:graphicData uri="http://schemas.openxmlformats.org/drawingml/2006/table">
+            <a:tbl>
+              <a:tblPr/>
+              <a:tblGrid>
+                <a:gridCol w="3383280"/>
+                <a:gridCol w="3017520"/>
+                <a:gridCol w="2651760"/>
+                <a:gridCol w="1828800"/>
+              </a:tblGrid>
+              <a:tr h="420624">
+                <a:tc>
+                  <a:txBody>
+                    <a:bodyPr/>
+                    <a:lstStyle/>
+                    <a:p>
+                      <a:pPr indent="0" marL="0">
+                        <a:buNone/>
+                      </a:pPr>
+                      <a:r>
+                        <a:rPr lang="en-US" sz="1250" b="1" dirty="0">
+                          <a:solidFill>
+                            <a:srgbClr val="1A1300"/>
+                          </a:solidFill>
+                          <a:latin typeface="Calibri" pitchFamily="34" charset="0"/>
+                          <a:ea typeface="Calibri" pitchFamily="34" charset="-122"/>
+                          <a:cs typeface="Calibri" pitchFamily="34" charset="-120"/>
+                        </a:rPr>
+                        <a:t>Mood input</a:t>
+                      </a:r>
+                      <a:endParaRPr lang="en-US" sz="1250" dirty="0">
+                        <a:latin typeface="Calibri" charset="0"/>
+                        <a:ea typeface="Calibri" charset="0"/>
+                        <a:cs typeface="Calibri" charset="0"/>
+                      </a:endParaRPr>
+                    </a:p>
+                  </a:txBody>
+                  <a:tcPr marL="63500" marR="63500" marT="63500" marB="63500" anchor="ctr">
+                    <a:lnL w="12700" cap="flat" cmpd="sng" algn="ctr">
+                      <a:solidFill>
+                        <a:srgbClr val="2A2F3E"/>
+                      </a:solidFill>
+                      <a:prstDash val="solid"/>
+                      <a:round/>
+                      <a:headEnd type="none" w="med" len="med"/>
+                      <a:tailEnd type="none" w="med" len="med"/>
+                    </a:lnL>
+                    <a:lnR w="12700" cap="flat" cmpd="sng" algn="ctr">
+                      <a:solidFill>
+                        <a:srgbClr val="2A2F3E"/>
+                      </a:solidFill>
+                      <a:prstDash val="solid"/>
+                      <a:round/>
+                      <a:headEnd type="none" w="med" len="med"/>
+                      <a:tailEnd type="none" w="med" len="med"/>
+                    </a:lnR>
+                    <a:lnT w="12700" cap="flat" cmpd="sng" algn="ctr">
+                      <a:solidFill>
+                        <a:srgbClr val="2A2F3E"/>
+                      </a:solidFill>
+                      <a:prstDash val="solid"/>
+                      <a:round/>
+                      <a:headEnd type="none" w="med" len="med"/>
+                      <a:tailEnd type="none" w="med" len="med"/>
+                    </a:lnT>
+                    <a:lnB w="12700" cap="flat" cmpd="sng" algn="ctr">
+                      <a:solidFill>
+                        <a:srgbClr val="2A2F3E"/>
+                      </a:solidFill>
+                      <a:prstDash val="solid"/>
+                      <a:round/>
+                      <a:headEnd type="none" w="med" len="med"/>
+                      <a:tailEnd type="none" w="med" len="med"/>
+                    </a:lnB>
+                    <a:solidFill>
+                      <a:srgbClr val="FFB347"/>
+                    </a:solidFill>
+                  </a:tcPr>
+                </a:tc>
+                <a:tc>
+                  <a:txBody>
+                    <a:bodyPr/>
+                    <a:lstStyle/>
+                    <a:p>
+                      <a:pPr indent="0" marL="0">
+                        <a:buNone/>
+                      </a:pPr>
+                      <a:r>
+                        <a:rPr lang="en-US" sz="1250" b="1" dirty="0">
+                          <a:solidFill>
+                            <a:srgbClr val="1A1300"/>
+                          </a:solidFill>
+                          <a:latin typeface="Calibri" pitchFamily="34" charset="0"/>
+                          <a:ea typeface="Calibri" pitchFamily="34" charset="-122"/>
+                          <a:cs typeface="Calibri" pitchFamily="34" charset="-120"/>
+                        </a:rPr>
+                        <a:t>Expected preferences</a:t>
+                      </a:r>
+                      <a:endParaRPr lang="en-US" sz="1250" dirty="0">
+                        <a:latin typeface="Calibri" charset="0"/>
+                        <a:ea typeface="Calibri" charset="0"/>
+                        <a:cs typeface="Calibri" charset="0"/>
+                      </a:endParaRPr>
+                    </a:p>
+                  </a:txBody>
+                  <a:tcPr marL="63500" marR="63500" marT="63500" marB="63500" anchor="ctr">
+                    <a:lnL w="12700" cap="flat" cmpd="sng" algn="ctr">
+                      <a:solidFill>
+                        <a:srgbClr val="2A2F3E"/>
+                      </a:solidFill>
+                      <a:prstDash val="solid"/>
+                      <a:round/>
+                      <a:headEnd type="none" w="med" len="med"/>
+                      <a:tailEnd type="none" w="med" len="med"/>
+                    </a:lnL>
+                    <a:lnR w="12700" cap="flat" cmpd="sng" algn="ctr">
+                      <a:solidFill>
+                        <a:srgbClr val="2A2F3E"/>
+                      </a:solidFill>
+                      <a:prstDash val="solid"/>
+                      <a:round/>
+                      <a:headEnd type="none" w="med" len="med"/>
+                      <a:tailEnd type="none" w="med" len="med"/>
+                    </a:lnR>
+                    <a:lnT w="12700" cap="flat" cmpd="sng" algn="ctr">
+                      <a:solidFill>
+                        <a:srgbClr val="2A2F3E"/>
+                      </a:solidFill>
+                      <a:prstDash val="solid"/>
+                      <a:round/>
+                      <a:headEnd type="none" w="med" len="med"/>
+                      <a:tailEnd type="none" w="med" len="med"/>
+                    </a:lnT>
+                    <a:lnB w="12700" cap="flat" cmpd="sng" algn="ctr">
+                      <a:solidFill>
+                        <a:srgbClr val="2A2F3E"/>
+                      </a:solidFill>
+                      <a:prstDash val="solid"/>
+                      <a:round/>
+                      <a:headEnd type="none" w="med" len="med"/>
+                      <a:tailEnd type="none" w="med" len="med"/>
+                    </a:lnB>
+                    <a:solidFill>
+                      <a:srgbClr val="FFB347"/>
+                    </a:solidFill>
+                  </a:tcPr>
+                </a:tc>
+                <a:tc>
+                  <a:txBody>
+                    <a:bodyPr/>
+                    <a:lstStyle/>
+                    <a:p>
+                      <a:pPr indent="0" marL="0">
+                        <a:buNone/>
+                      </a:pPr>
+                      <a:r>
+                        <a:rPr lang="en-US" sz="1250" b="1" dirty="0">
+                          <a:solidFill>
+                            <a:srgbClr val="1A1300"/>
+                          </a:solidFill>
+                          <a:latin typeface="Calibri" pitchFamily="34" charset="0"/>
+                          <a:ea typeface="Calibri" pitchFamily="34" charset="-122"/>
+                          <a:cs typeface="Calibri" pitchFamily="34" charset="-120"/>
+                        </a:rPr>
+                        <a:t>Actual output</a:t>
+                      </a:r>
+                      <a:endParaRPr lang="en-US" sz="1250" dirty="0">
+                        <a:latin typeface="Calibri" charset="0"/>
+                        <a:ea typeface="Calibri" charset="0"/>
+                        <a:cs typeface="Calibri" charset="0"/>
+                      </a:endParaRPr>
+                    </a:p>
+                  </a:txBody>
+                  <a:tcPr marL="63500" marR="63500" marT="63500" marB="63500" anchor="ctr">
+                    <a:lnL w="12700" cap="flat" cmpd="sng" algn="ctr">
+                      <a:solidFill>
+                        <a:srgbClr val="2A2F3E"/>
+                      </a:solidFill>
+                      <a:prstDash val="solid"/>
+                      <a:round/>
+                      <a:headEnd type="none" w="med" len="med"/>
+                      <a:tailEnd type="none" w="med" len="med"/>
+                    </a:lnL>
+                    <a:lnR w="12700" cap="flat" cmpd="sng" algn="ctr">
+                      <a:solidFill>
+                        <a:srgbClr val="2A2F3E"/>
+                      </a:solidFill>
+                      <a:prstDash val="solid"/>
+                      <a:round/>
+                      <a:headEnd type="none" w="med" len="med"/>
+                      <a:tailEnd type="none" w="med" len="med"/>
+                    </a:lnR>
+                    <a:lnT w="12700" cap="flat" cmpd="sng" algn="ctr">
+                      <a:solidFill>
+                        <a:srgbClr val="2A2F3E"/>
+                      </a:solidFill>
+                      <a:prstDash val="solid"/>
+                      <a:round/>
+                      <a:headEnd type="none" w="med" len="med"/>
+                      <a:tailEnd type="none" w="med" len="med"/>
+                    </a:lnT>
+                    <a:lnB w="12700" cap="flat" cmpd="sng" algn="ctr">
+                      <a:solidFill>
+                        <a:srgbClr val="2A2F3E"/>
+                      </a:solidFill>
+                      <a:prstDash val="solid"/>
+                      <a:round/>
+                      <a:headEnd type="none" w="med" len="med"/>
+                      <a:tailEnd type="none" w="med" len="med"/>
+                    </a:lnB>
+                    <a:solidFill>
+                      <a:srgbClr val="FFB347"/>
+                    </a:solidFill>
+                  </a:tcPr>
+                </a:tc>
+                <a:tc>
+                  <a:txBody>
+                    <a:bodyPr/>
+                    <a:lstStyle/>
+                    <a:p>
+                      <a:pPr indent="0" marL="0">
+                        <a:buNone/>
+                      </a:pPr>
+                      <a:r>
+                        <a:rPr lang="en-US" sz="1250" b="1" dirty="0">
+                          <a:solidFill>
+                            <a:srgbClr val="1A1300"/>
+                          </a:solidFill>
+                          <a:latin typeface="Calibri" pitchFamily="34" charset="0"/>
+                          <a:ea typeface="Calibri" pitchFamily="34" charset="-122"/>
+                          <a:cs typeface="Calibri" pitchFamily="34" charset="-120"/>
+                        </a:rPr>
+                        <a:t>Result</a:t>
+                      </a:r>
+                      <a:endParaRPr lang="en-US" sz="1250" dirty="0">
+                        <a:latin typeface="Calibri" charset="0"/>
+                        <a:ea typeface="Calibri" charset="0"/>
+                        <a:cs typeface="Calibri" charset="0"/>
+                      </a:endParaRPr>
+                    </a:p>
+                  </a:txBody>
+                  <a:tcPr marL="63500" marR="63500" marT="63500" marB="63500" anchor="ctr">
+                    <a:lnL w="12700" cap="flat" cmpd="sng" algn="ctr">
+                      <a:solidFill>
+                        <a:srgbClr val="2A2F3E"/>
+                      </a:solidFill>
+                      <a:prstDash val="solid"/>
+                      <a:round/>
+                      <a:headEnd type="none" w="med" len="med"/>
+                      <a:tailEnd type="none" w="med" len="med"/>
+                    </a:lnL>
+                    <a:lnR w="12700" cap="flat" cmpd="sng" algn="ctr">
+                      <a:solidFill>
+                        <a:srgbClr val="2A2F3E"/>
+                      </a:solidFill>
+                      <a:prstDash val="solid"/>
+                      <a:round/>
+                      <a:headEnd type="none" w="med" len="med"/>
+                      <a:tailEnd type="none" w="med" len="med"/>
+                    </a:lnR>
+                    <a:lnT w="12700" cap="flat" cmpd="sng" algn="ctr">
+                      <a:solidFill>
+                        <a:srgbClr val="2A2F3E"/>
+                      </a:solidFill>
+                      <a:prstDash val="solid"/>
+                      <a:round/>
+                      <a:headEnd type="none" w="med" len="med"/>
+                      <a:tailEnd type="none" w="med" len="med"/>
+                    </a:lnT>
+                    <a:lnB w="12700" cap="flat" cmpd="sng" algn="ctr">
+                      <a:solidFill>
+                        <a:srgbClr val="2A2F3E"/>
+                      </a:solidFill>
+                      <a:prstDash val="solid"/>
+                      <a:round/>
+                      <a:headEnd type="none" w="med" len="med"/>
+                      <a:tailEnd type="none" w="med" len="med"/>
+                    </a:lnB>
+                    <a:solidFill>
+                      <a:srgbClr val="FFB347"/>
+                    </a:solidFill>
+                  </a:tcPr>
+                </a:tc>
+              </a:tr>
+              <a:tr h="420624">
+                <a:tc>
+                  <a:txBody>
+                    <a:bodyPr/>
+                    <a:lstStyle/>
+                    <a:p>
+                      <a:pPr indent="0" marL="0">
+                        <a:buNone/>
+                      </a:pPr>
+                      <a:r>
+                        <a:rPr lang="en-US" sz="1200" dirty="0">
+                          <a:solidFill>
+                            <a:srgbClr val="ECECF3"/>
+                          </a:solidFill>
+                          <a:latin typeface="Calibri" pitchFamily="34" charset="0"/>
+                          <a:ea typeface="Calibri" pitchFamily="34" charset="-122"/>
+                          <a:cs typeface="Calibri" pitchFamily="34" charset="-120"/>
+                        </a:rPr>
+                        <a:t>"relaxing cozy solo night"</a:t>
+                      </a:r>
+                      <a:endParaRPr lang="en-US" sz="1200" dirty="0">
+                        <a:latin typeface="Calibri" charset="0"/>
+                        <a:ea typeface="Calibri" charset="0"/>
+                        <a:cs typeface="Calibri" charset="0"/>
+                      </a:endParaRPr>
+                    </a:p>
+                  </a:txBody>
+                  <a:tcPr marL="63500" marR="63500" marT="63500" marB="63500" anchor="ctr">
+                    <a:lnL w="12700" cap="flat" cmpd="sng" algn="ctr">
+                      <a:solidFill>
+                        <a:srgbClr val="2A2F3E"/>
+                      </a:solidFill>
+                      <a:prstDash val="solid"/>
+                      <a:round/>
+                      <a:headEnd type="none" w="med" len="med"/>
+                      <a:tailEnd type="none" w="med" len="med"/>
+                    </a:lnL>
+                    <a:lnR w="12700" cap="flat" cmpd="sng" algn="ctr">
+                      <a:solidFill>
+                        <a:srgbClr val="2A2F3E"/>
+                      </a:solidFill>
+                      <a:prstDash val="solid"/>
+                      <a:round/>
+                      <a:headEnd type="none" w="med" len="med"/>
+                      <a:tailEnd type="none" w="med" len="med"/>
+                    </a:lnR>
+                    <a:lnT w="12700" cap="flat" cmpd="sng" algn="ctr">
+                      <a:solidFill>
+                        <a:srgbClr val="2A2F3E"/>
+                      </a:solidFill>
+                      <a:prstDash val="solid"/>
+                      <a:round/>
+                      <a:headEnd type="none" w="med" len="med"/>
+                      <a:tailEnd type="none" w="med" len="med"/>
+                    </a:lnT>
+                    <a:lnB w="12700" cap="flat" cmpd="sng" algn="ctr">
+                      <a:solidFill>
+                        <a:srgbClr val="2A2F3E"/>
+                      </a:solidFill>
+                      <a:prstDash val="solid"/>
+                      <a:round/>
+                      <a:headEnd type="none" w="med" len="med"/>
+                      <a:tailEnd type="none" w="med" len="med"/>
+                    </a:lnB>
+                    <a:solidFill>
+                      <a:srgbClr val="1A1D27"/>
+                    </a:solidFill>
+                  </a:tcPr>
+                </a:tc>
+                <a:tc>
+                  <a:txBody>
+                    <a:bodyPr/>
+                    <a:lstStyle/>
+                    <a:p>
+                      <a:pPr indent="0" marL="0">
+                        <a:buNone/>
+                      </a:pPr>
+                      <a:r>
+                        <a:rPr lang="en-US" sz="1200" dirty="0">
+                          <a:solidFill>
+                            <a:srgbClr val="ECECF3"/>
+                          </a:solidFill>
+                          <a:latin typeface="Calibri" pitchFamily="34" charset="0"/>
+                          <a:ea typeface="Calibri" pitchFamily="34" charset="-122"/>
+                          <a:cs typeface="Calibri" pitchFamily="34" charset="-120"/>
+                        </a:rPr>
+                        <a:t>Cozy · Relaxed · solo</a:t>
+                      </a:r>
+                      <a:endParaRPr lang="en-US" sz="1200" dirty="0">
+                        <a:latin typeface="Calibri" charset="0"/>
+                        <a:ea typeface="Calibri" charset="0"/>
+                        <a:cs typeface="Calibri" charset="0"/>
+                      </a:endParaRPr>
+                    </a:p>
+                  </a:txBody>
+                  <a:tcPr marL="63500" marR="63500" marT="63500" marB="63500" anchor="ctr">
+                    <a:lnL w="12700" cap="flat" cmpd="sng" algn="ctr">
+                      <a:solidFill>
+                        <a:srgbClr val="2A2F3E"/>
+                      </a:solidFill>
+                      <a:prstDash val="solid"/>
+                      <a:round/>
+                      <a:headEnd type="none" w="med" len="med"/>
+                      <a:tailEnd type="none" w="med" len="med"/>
+                    </a:lnL>
+                    <a:lnR w="12700" cap="flat" cmpd="sng" algn="ctr">
+                      <a:solidFill>
+                        <a:srgbClr val="2A2F3E"/>
+                      </a:solidFill>
+                      <a:prstDash val="solid"/>
+                      <a:round/>
+                      <a:headEnd type="none" w="med" len="med"/>
+                      <a:tailEnd type="none" w="med" len="med"/>
+                    </a:lnR>
+                    <a:lnT w="12700" cap="flat" cmpd="sng" algn="ctr">
+                      <a:solidFill>
+                        <a:srgbClr val="2A2F3E"/>
+                      </a:solidFill>
+                      <a:prstDash val="solid"/>
+                      <a:round/>
+                      <a:headEnd type="none" w="med" len="med"/>
+                      <a:tailEnd type="none" w="med" len="med"/>
+                    </a:lnT>
+                    <a:lnB w="12700" cap="flat" cmpd="sng" algn="ctr">
+                      <a:solidFill>
+                        <a:srgbClr val="2A2F3E"/>
+                      </a:solidFill>
+                      <a:prstDash val="solid"/>
+                      <a:round/>
+                      <a:headEnd type="none" w="med" len="med"/>
+                      <a:tailEnd type="none" w="med" len="med"/>
+                    </a:lnB>
+                    <a:solidFill>
+                      <a:srgbClr val="1A1D27"/>
+                    </a:solidFill>
+                  </a:tcPr>
+                </a:tc>
+                <a:tc>
+                  <a:txBody>
+                    <a:bodyPr/>
+                    <a:lstStyle/>
+                    <a:p>
+                      <a:pPr indent="0" marL="0">
+                        <a:buNone/>
+                      </a:pPr>
+                      <a:r>
+                        <a:rPr lang="en-US" sz="1200" dirty="0">
+                          <a:solidFill>
+                            <a:srgbClr val="ECECF3"/>
+                          </a:solidFill>
+                          <a:latin typeface="Calibri" pitchFamily="34" charset="0"/>
+                          <a:ea typeface="Calibri" pitchFamily="34" charset="-122"/>
+                          <a:cs typeface="Calibri" pitchFamily="34" charset="-120"/>
+                        </a:rPr>
+                        <a:t>🎮 Balatro (2024)</a:t>
+                      </a:r>
+                      <a:endParaRPr lang="en-US" sz="1200" dirty="0">
+                        <a:latin typeface="Calibri" charset="0"/>
+                        <a:ea typeface="Calibri" charset="0"/>
+                        <a:cs typeface="Calibri" charset="0"/>
+                      </a:endParaRPr>
+                    </a:p>
+                  </a:txBody>
+                  <a:tcPr marL="63500" marR="63500" marT="63500" marB="63500" anchor="ctr">
+                    <a:lnL w="12700" cap="flat" cmpd="sng" algn="ctr">
+                      <a:solidFill>
+                        <a:srgbClr val="2A2F3E"/>
+                      </a:solidFill>
+                      <a:prstDash val="solid"/>
+                      <a:round/>
+                      <a:headEnd type="none" w="med" len="med"/>
+                      <a:tailEnd type="none" w="med" len="med"/>
+                    </a:lnL>
+                    <a:lnR w="12700" cap="flat" cmpd="sng" algn="ctr">
+                      <a:solidFill>
+                        <a:srgbClr val="2A2F3E"/>
+                      </a:solidFill>
+                      <a:prstDash val="solid"/>
+                      <a:round/>
+                      <a:headEnd type="none" w="med" len="med"/>
+                      <a:tailEnd type="none" w="med" len="med"/>
+                    </a:lnR>
+                    <a:lnT w="12700" cap="flat" cmpd="sng" algn="ctr">
+                      <a:solidFill>
+                        <a:srgbClr val="2A2F3E"/>
+                      </a:solidFill>
+                      <a:prstDash val="solid"/>
+                      <a:round/>
+                      <a:headEnd type="none" w="med" len="med"/>
+                      <a:tailEnd type="none" w="med" len="med"/>
+                    </a:lnT>
+                    <a:lnB w="12700" cap="flat" cmpd="sng" algn="ctr">
+                      <a:solidFill>
+                        <a:srgbClr val="2A2F3E"/>
+                      </a:solidFill>
+                      <a:prstDash val="solid"/>
+                      <a:round/>
+                      <a:headEnd type="none" w="med" len="med"/>
+                      <a:tailEnd type="none" w="med" len="med"/>
+                    </a:lnB>
+                    <a:solidFill>
+                      <a:srgbClr val="1A1D27"/>
+                    </a:solidFill>
+                  </a:tcPr>
+                </a:tc>
+                <a:tc>
+                  <a:txBody>
+                    <a:bodyPr/>
+                    <a:lstStyle/>
+                    <a:p>
+                      <a:pPr algn="ctr" indent="0" marL="0">
+                        <a:buNone/>
+                      </a:pPr>
+                      <a:r>
+                        <a:rPr lang="en-US" sz="1200" b="1" dirty="0">
+                          <a:solidFill>
+                            <a:srgbClr val="5BC8AF"/>
+                          </a:solidFill>
+                          <a:latin typeface="Calibri" pitchFamily="34" charset="0"/>
+                          <a:ea typeface="Calibri" pitchFamily="34" charset="-122"/>
+                          <a:cs typeface="Calibri" pitchFamily="34" charset="-120"/>
+                        </a:rPr>
+                        <a:t>✓ Pass</a:t>
+                      </a:r>
+                      <a:endParaRPr lang="en-US" sz="1200" dirty="0">
+                        <a:latin typeface="Calibri" charset="0"/>
+                        <a:ea typeface="Calibri" charset="0"/>
+                        <a:cs typeface="Calibri" charset="0"/>
+                      </a:endParaRPr>
+                    </a:p>
+                  </a:txBody>
+                  <a:tcPr marL="63500" marR="63500" marT="63500" marB="63500" anchor="ctr">
+                    <a:lnL w="12700" cap="flat" cmpd="sng" algn="ctr">
+                      <a:solidFill>
+                        <a:srgbClr val="2A2F3E"/>
+                      </a:solidFill>
+                      <a:prstDash val="solid"/>
+                      <a:round/>
+                      <a:headEnd type="none" w="med" len="med"/>
+                      <a:tailEnd type="none" w="med" len="med"/>
+                    </a:lnL>
+                    <a:lnR w="12700" cap="flat" cmpd="sng" algn="ctr">
+                      <a:solidFill>
+                        <a:srgbClr val="2A2F3E"/>
+                      </a:solidFill>
+                      <a:prstDash val="solid"/>
+                      <a:round/>
+                      <a:headEnd type="none" w="med" len="med"/>
+                      <a:tailEnd type="none" w="med" len="med"/>
+                    </a:lnR>
+                    <a:lnT w="12700" cap="flat" cmpd="sng" algn="ctr">
+                      <a:solidFill>
+                        <a:srgbClr val="2A2F3E"/>
+                      </a:solidFill>
+                      <a:prstDash val="solid"/>
+                      <a:round/>
+                      <a:headEnd type="none" w="med" len="med"/>
+                      <a:tailEnd type="none" w="med" len="med"/>
+                    </a:lnT>
+                    <a:lnB w="12700" cap="flat" cmpd="sng" algn="ctr">
+                      <a:solidFill>
+                        <a:srgbClr val="2A2F3E"/>
+                      </a:solidFill>
+                      <a:prstDash val="solid"/>
+                      <a:round/>
+                      <a:headEnd type="none" w="med" len="med"/>
+                      <a:tailEnd type="none" w="med" len="med"/>
+                    </a:lnB>
+                    <a:solidFill>
+                      <a:srgbClr val="1A1D27"/>
+                    </a:solidFill>
+                  </a:tcPr>
+                </a:tc>
+              </a:tr>
+              <a:tr h="420624">
+                <a:tc>
+                  <a:txBody>
+                    <a:bodyPr/>
+                    <a:lstStyle/>
+                    <a:p>
+                      <a:pPr indent="0" marL="0">
+                        <a:buNone/>
+                      </a:pPr>
+                      <a:r>
+                        <a:rPr lang="en-US" sz="1200" dirty="0">
+                          <a:solidFill>
+                            <a:srgbClr val="ECECF3"/>
+                          </a:solidFill>
+                          <a:latin typeface="Calibri" pitchFamily="34" charset="0"/>
+                          <a:ea typeface="Calibri" pitchFamily="34" charset="-122"/>
+                          <a:cs typeface="Calibri" pitchFamily="34" charset="-120"/>
+                        </a:rPr>
+                        <a:t>"scary horror with a group"</a:t>
+                      </a:r>
+                      <a:endParaRPr lang="en-US" sz="1200" dirty="0">
+                        <a:latin typeface="Calibri" charset="0"/>
+                        <a:ea typeface="Calibri" charset="0"/>
+                        <a:cs typeface="Calibri" charset="0"/>
+                      </a:endParaRPr>
+                    </a:p>
+                  </a:txBody>
+                  <a:tcPr marL="63500" marR="63500" marT="63500" marB="63500" anchor="ctr">
+                    <a:lnL w="12700" cap="flat" cmpd="sng" algn="ctr">
+                      <a:solidFill>
+                        <a:srgbClr val="2A2F3E"/>
+                      </a:solidFill>
+                      <a:prstDash val="solid"/>
+                      <a:round/>
+                      <a:headEnd type="none" w="med" len="med"/>
+                      <a:tailEnd type="none" w="med" len="med"/>
+                    </a:lnL>
+                    <a:lnR w="12700" cap="flat" cmpd="sng" algn="ctr">
+                      <a:solidFill>
+                        <a:srgbClr val="2A2F3E"/>
+                      </a:solidFill>
+                      <a:prstDash val="solid"/>
+                      <a:round/>
+                      <a:headEnd type="none" w="med" len="med"/>
+                      <a:tailEnd type="none" w="med" len="med"/>
+                    </a:lnR>
+                    <a:lnT w="12700" cap="flat" cmpd="sng" algn="ctr">
+                      <a:solidFill>
+                        <a:srgbClr val="2A2F3E"/>
+                      </a:solidFill>
+                      <a:prstDash val="solid"/>
+                      <a:round/>
+                      <a:headEnd type="none" w="med" len="med"/>
+                      <a:tailEnd type="none" w="med" len="med"/>
+                    </a:lnT>
+                    <a:lnB w="12700" cap="flat" cmpd="sng" algn="ctr">
+                      <a:solidFill>
+                        <a:srgbClr val="2A2F3E"/>
+                      </a:solidFill>
+                      <a:prstDash val="solid"/>
+                      <a:round/>
+                      <a:headEnd type="none" w="med" len="med"/>
+                      <a:tailEnd type="none" w="med" len="med"/>
+                    </a:lnB>
+                    <a:solidFill>
+                      <a:srgbClr val="1A1D27"/>
+                    </a:solidFill>
+                  </a:tcPr>
+                </a:tc>
+                <a:tc>
+                  <a:txBody>
+                    <a:bodyPr/>
+                    <a:lstStyle/>
+                    <a:p>
+                      <a:pPr indent="0" marL="0">
+                        <a:buNone/>
+                      </a:pPr>
+                      <a:r>
+                        <a:rPr lang="en-US" sz="1200" dirty="0">
+                          <a:solidFill>
+                            <a:srgbClr val="ECECF3"/>
+                          </a:solidFill>
+                          <a:latin typeface="Calibri" pitchFamily="34" charset="0"/>
+                          <a:ea typeface="Calibri" pitchFamily="34" charset="-122"/>
+                          <a:cs typeface="Calibri" pitchFamily="34" charset="-120"/>
+                        </a:rPr>
+                        <a:t>Horror · Intense · group</a:t>
+                      </a:r>
+                      <a:endParaRPr lang="en-US" sz="1200" dirty="0">
+                        <a:latin typeface="Calibri" charset="0"/>
+                        <a:ea typeface="Calibri" charset="0"/>
+                        <a:cs typeface="Calibri" charset="0"/>
+                      </a:endParaRPr>
+                    </a:p>
+                  </a:txBody>
+                  <a:tcPr marL="63500" marR="63500" marT="63500" marB="63500" anchor="ctr">
+                    <a:lnL w="12700" cap="flat" cmpd="sng" algn="ctr">
+                      <a:solidFill>
+                        <a:srgbClr val="2A2F3E"/>
+                      </a:solidFill>
+                      <a:prstDash val="solid"/>
+                      <a:round/>
+                      <a:headEnd type="none" w="med" len="med"/>
+                      <a:tailEnd type="none" w="med" len="med"/>
+                    </a:lnL>
+                    <a:lnR w="12700" cap="flat" cmpd="sng" algn="ctr">
+                      <a:solidFill>
+                        <a:srgbClr val="2A2F3E"/>
+                      </a:solidFill>
+                      <a:prstDash val="solid"/>
+                      <a:round/>
+                      <a:headEnd type="none" w="med" len="med"/>
+                      <a:tailEnd type="none" w="med" len="med"/>
+                    </a:lnR>
+                    <a:lnT w="12700" cap="flat" cmpd="sng" algn="ctr">
+                      <a:solidFill>
+                        <a:srgbClr val="2A2F3E"/>
+                      </a:solidFill>
+                      <a:prstDash val="solid"/>
+                      <a:round/>
+                      <a:headEnd type="none" w="med" len="med"/>
+                      <a:tailEnd type="none" w="med" len="med"/>
+                    </a:lnT>
+                    <a:lnB w="12700" cap="flat" cmpd="sng" algn="ctr">
+                      <a:solidFill>
+                        <a:srgbClr val="2A2F3E"/>
+                      </a:solidFill>
+                      <a:prstDash val="solid"/>
+                      <a:round/>
+                      <a:headEnd type="none" w="med" len="med"/>
+                      <a:tailEnd type="none" w="med" len="med"/>
+                    </a:lnB>
+                    <a:solidFill>
+                      <a:srgbClr val="1A1D27"/>
+                    </a:solidFill>
+                  </a:tcPr>
+                </a:tc>
+                <a:tc>
+                  <a:txBody>
+                    <a:bodyPr/>
+                    <a:lstStyle/>
+                    <a:p>
+                      <a:pPr indent="0" marL="0">
+                        <a:buNone/>
+                      </a:pPr>
+                      <a:r>
+                        <a:rPr lang="en-US" sz="1200" dirty="0">
+                          <a:solidFill>
+                            <a:srgbClr val="ECECF3"/>
+                          </a:solidFill>
+                          <a:latin typeface="Calibri" pitchFamily="34" charset="0"/>
+                          <a:ea typeface="Calibri" pitchFamily="34" charset="-122"/>
+                          <a:cs typeface="Calibri" pitchFamily="34" charset="-120"/>
+                        </a:rPr>
+                        <a:t>🎬 Alien (1979)</a:t>
+                      </a:r>
+                      <a:endParaRPr lang="en-US" sz="1200" dirty="0">
+                        <a:latin typeface="Calibri" charset="0"/>
+                        <a:ea typeface="Calibri" charset="0"/>
+                        <a:cs typeface="Calibri" charset="0"/>
+                      </a:endParaRPr>
+                    </a:p>
+                  </a:txBody>
+                  <a:tcPr marL="63500" marR="63500" marT="63500" marB="63500" anchor="ctr">
+                    <a:lnL w="12700" cap="flat" cmpd="sng" algn="ctr">
+                      <a:solidFill>
+                        <a:srgbClr val="2A2F3E"/>
+                      </a:solidFill>
+                      <a:prstDash val="solid"/>
+                      <a:round/>
+                      <a:headEnd type="none" w="med" len="med"/>
+                      <a:tailEnd type="none" w="med" len="med"/>
+                    </a:lnL>
+                    <a:lnR w="12700" cap="flat" cmpd="sng" algn="ctr">
+                      <a:solidFill>
+                        <a:srgbClr val="2A2F3E"/>
+                      </a:solidFill>
+                      <a:prstDash val="solid"/>
+                      <a:round/>
+                      <a:headEnd type="none" w="med" len="med"/>
+                      <a:tailEnd type="none" w="med" len="med"/>
+                    </a:lnR>
+                    <a:lnT w="12700" cap="flat" cmpd="sng" algn="ctr">
+                      <a:solidFill>
+                        <a:srgbClr val="2A2F3E"/>
+                      </a:solidFill>
+                      <a:prstDash val="solid"/>
+                      <a:round/>
+                      <a:headEnd type="none" w="med" len="med"/>
+                      <a:tailEnd type="none" w="med" len="med"/>
+                    </a:lnT>
+                    <a:lnB w="12700" cap="flat" cmpd="sng" algn="ctr">
+                      <a:solidFill>
+                        <a:srgbClr val="2A2F3E"/>
+                      </a:solidFill>
+                      <a:prstDash val="solid"/>
+                      <a:round/>
+                      <a:headEnd type="none" w="med" len="med"/>
+                      <a:tailEnd type="none" w="med" len="med"/>
+                    </a:lnB>
+                    <a:solidFill>
+                      <a:srgbClr val="1A1D27"/>
+                    </a:solidFill>
+                  </a:tcPr>
+                </a:tc>
+                <a:tc>
+                  <a:txBody>
+                    <a:bodyPr/>
+                    <a:lstStyle/>
+                    <a:p>
+                      <a:pPr algn="ctr" indent="0" marL="0">
+                        <a:buNone/>
+                      </a:pPr>
+                      <a:r>
+                        <a:rPr lang="en-US" sz="1200" b="1" dirty="0">
+                          <a:solidFill>
+                            <a:srgbClr val="5BC8AF"/>
+                          </a:solidFill>
+                          <a:latin typeface="Calibri" pitchFamily="34" charset="0"/>
+                          <a:ea typeface="Calibri" pitchFamily="34" charset="-122"/>
+                          <a:cs typeface="Calibri" pitchFamily="34" charset="-120"/>
+                        </a:rPr>
+                        <a:t>✓ Pass</a:t>
+                      </a:r>
+                      <a:endParaRPr lang="en-US" sz="1200" dirty="0">
+                        <a:latin typeface="Calibri" charset="0"/>
+                        <a:ea typeface="Calibri" charset="0"/>
+                        <a:cs typeface="Calibri" charset="0"/>
+                      </a:endParaRPr>
+                    </a:p>
+                  </a:txBody>
+                  <a:tcPr marL="63500" marR="63500" marT="63500" marB="63500" anchor="ctr">
+                    <a:lnL w="12700" cap="flat" cmpd="sng" algn="ctr">
+                      <a:solidFill>
+                        <a:srgbClr val="2A2F3E"/>
+                      </a:solidFill>
+                      <a:prstDash val="solid"/>
+                      <a:round/>
+                      <a:headEnd type="none" w="med" len="med"/>
+                      <a:tailEnd type="none" w="med" len="med"/>
+                    </a:lnL>
+                    <a:lnR w="12700" cap="flat" cmpd="sng" algn="ctr">
+                      <a:solidFill>
+                        <a:srgbClr val="2A2F3E"/>
+                      </a:solidFill>
+                      <a:prstDash val="solid"/>
+                      <a:round/>
+                      <a:headEnd type="none" w="med" len="med"/>
+                      <a:tailEnd type="none" w="med" len="med"/>
+                    </a:lnR>
+                    <a:lnT w="12700" cap="flat" cmpd="sng" algn="ctr">
+                      <a:solidFill>
+                        <a:srgbClr val="2A2F3E"/>
+                      </a:solidFill>
+                      <a:prstDash val="solid"/>
+                      <a:round/>
+                      <a:headEnd type="none" w="med" len="med"/>
+                      <a:tailEnd type="none" w="med" len="med"/>
+                    </a:lnT>
+                    <a:lnB w="12700" cap="flat" cmpd="sng" algn="ctr">
+                      <a:solidFill>
+                        <a:srgbClr val="2A2F3E"/>
+                      </a:solidFill>
+                      <a:prstDash val="solid"/>
+                      <a:round/>
+                      <a:headEnd type="none" w="med" len="med"/>
+                      <a:tailEnd type="none" w="med" len="med"/>
+                    </a:lnB>
+                    <a:solidFill>
+                      <a:srgbClr val="1A1D27"/>
+                    </a:solidFill>
+                  </a:tcPr>
+                </a:tc>
+              </a:tr>
+              <a:tr h="420624">
+                <a:tc>
+                  <a:txBody>
+                    <a:bodyPr/>
+                    <a:lstStyle/>
+                    <a:p>
+                      <a:pPr indent="0" marL="0">
+                        <a:buNone/>
+                      </a:pPr>
+                      <a:r>
+                        <a:rPr lang="en-US" sz="1200" dirty="0">
+                          <a:solidFill>
+                            <a:srgbClr val="ECECF3"/>
+                          </a:solidFill>
+                          <a:latin typeface="Calibri" pitchFamily="34" charset="0"/>
+                          <a:ea typeface="Calibri" pitchFamily="34" charset="-122"/>
+                          <a:cs typeface="Calibri" pitchFamily="34" charset="-120"/>
+                        </a:rPr>
+                        <a:t>"epic action game for hours"</a:t>
+                      </a:r>
+                      <a:endParaRPr lang="en-US" sz="1200" dirty="0">
+                        <a:latin typeface="Calibri" charset="0"/>
+                        <a:ea typeface="Calibri" charset="0"/>
+                        <a:cs typeface="Calibri" charset="0"/>
+                      </a:endParaRPr>
+                    </a:p>
+                  </a:txBody>
+                  <a:tcPr marL="63500" marR="63500" marT="63500" marB="63500" anchor="ctr">
+                    <a:lnL w="12700" cap="flat" cmpd="sng" algn="ctr">
+                      <a:solidFill>
+                        <a:srgbClr val="2A2F3E"/>
+                      </a:solidFill>
+                      <a:prstDash val="solid"/>
+                      <a:round/>
+                      <a:headEnd type="none" w="med" len="med"/>
+                      <a:tailEnd type="none" w="med" len="med"/>
+                    </a:lnL>
+                    <a:lnR w="12700" cap="flat" cmpd="sng" algn="ctr">
+                      <a:solidFill>
+                        <a:srgbClr val="2A2F3E"/>
+                      </a:solidFill>
+                      <a:prstDash val="solid"/>
+                      <a:round/>
+                      <a:headEnd type="none" w="med" len="med"/>
+                      <a:tailEnd type="none" w="med" len="med"/>
+                    </a:lnR>
+                    <a:lnT w="12700" cap="flat" cmpd="sng" algn="ctr">
+                      <a:solidFill>
+                        <a:srgbClr val="2A2F3E"/>
+                      </a:solidFill>
+                      <a:prstDash val="solid"/>
+                      <a:round/>
+                      <a:headEnd type="none" w="med" len="med"/>
+                      <a:tailEnd type="none" w="med" len="med"/>
+                    </a:lnT>
+                    <a:lnB w="12700" cap="flat" cmpd="sng" algn="ctr">
+                      <a:solidFill>
+                        <a:srgbClr val="2A2F3E"/>
+                      </a:solidFill>
+                      <a:prstDash val="solid"/>
+                      <a:round/>
+                      <a:headEnd type="none" w="med" len="med"/>
+                      <a:tailEnd type="none" w="med" len="med"/>
+                    </a:lnB>
+                    <a:solidFill>
+                      <a:srgbClr val="1A1D27"/>
+                    </a:solidFill>
+                  </a:tcPr>
+                </a:tc>
+                <a:tc>
+                  <a:txBody>
+                    <a:bodyPr/>
+                    <a:lstStyle/>
+                    <a:p>
+                      <a:pPr indent="0" marL="0">
+                        <a:buNone/>
+                      </a:pPr>
+                      <a:r>
+                        <a:rPr lang="en-US" sz="1200" dirty="0">
+                          <a:solidFill>
+                            <a:srgbClr val="ECECF3"/>
+                          </a:solidFill>
+                          <a:latin typeface="Calibri" pitchFamily="34" charset="0"/>
+                          <a:ea typeface="Calibri" pitchFamily="34" charset="-122"/>
+                          <a:cs typeface="Calibri" pitchFamily="34" charset="-120"/>
+                        </a:rPr>
+                        <a:t>Action · long · solo</a:t>
+                      </a:r>
+                      <a:endParaRPr lang="en-US" sz="1200" dirty="0">
+                        <a:latin typeface="Calibri" charset="0"/>
+                        <a:ea typeface="Calibri" charset="0"/>
+                        <a:cs typeface="Calibri" charset="0"/>
+                      </a:endParaRPr>
+                    </a:p>
+                  </a:txBody>
+                  <a:tcPr marL="63500" marR="63500" marT="63500" marB="63500" anchor="ctr">
+                    <a:lnL w="12700" cap="flat" cmpd="sng" algn="ctr">
+                      <a:solidFill>
+                        <a:srgbClr val="2A2F3E"/>
+                      </a:solidFill>
+                      <a:prstDash val="solid"/>
+                      <a:round/>
+                      <a:headEnd type="none" w="med" len="med"/>
+                      <a:tailEnd type="none" w="med" len="med"/>
+                    </a:lnL>
+                    <a:lnR w="12700" cap="flat" cmpd="sng" algn="ctr">
+                      <a:solidFill>
+                        <a:srgbClr val="2A2F3E"/>
+                      </a:solidFill>
+                      <a:prstDash val="solid"/>
+                      <a:round/>
+                      <a:headEnd type="none" w="med" len="med"/>
+                      <a:tailEnd type="none" w="med" len="med"/>
+                    </a:lnR>
+                    <a:lnT w="12700" cap="flat" cmpd="sng" algn="ctr">
+                      <a:solidFill>
+                        <a:srgbClr val="2A2F3E"/>
+                      </a:solidFill>
+                      <a:prstDash val="solid"/>
+                      <a:round/>
+                      <a:headEnd type="none" w="med" len="med"/>
+                      <a:tailEnd type="none" w="med" len="med"/>
+                    </a:lnT>
+                    <a:lnB w="12700" cap="flat" cmpd="sng" algn="ctr">
+                      <a:solidFill>
+                        <a:srgbClr val="2A2F3E"/>
+                      </a:solidFill>
+                      <a:prstDash val="solid"/>
+                      <a:round/>
+                      <a:headEnd type="none" w="med" len="med"/>
+                      <a:tailEnd type="none" w="med" len="med"/>
+                    </a:lnB>
+                    <a:solidFill>
+                      <a:srgbClr val="1A1D27"/>
+                    </a:solidFill>
+                  </a:tcPr>
+                </a:tc>
+                <a:tc>
+                  <a:txBody>
+                    <a:bodyPr/>
+                    <a:lstStyle/>
+                    <a:p>
+                      <a:pPr indent="0" marL="0">
+                        <a:buNone/>
+                      </a:pPr>
+                      <a:r>
+                        <a:rPr lang="en-US" sz="1200" dirty="0">
+                          <a:solidFill>
+                            <a:srgbClr val="ECECF3"/>
+                          </a:solidFill>
+                          <a:latin typeface="Calibri" pitchFamily="34" charset="0"/>
+                          <a:ea typeface="Calibri" pitchFamily="34" charset="-122"/>
+                          <a:cs typeface="Calibri" pitchFamily="34" charset="-120"/>
+                        </a:rPr>
+                        <a:t>🎮 Super Mario Odyssey</a:t>
+                      </a:r>
+                      <a:endParaRPr lang="en-US" sz="1200" dirty="0">
+                        <a:latin typeface="Calibri" charset="0"/>
+                        <a:ea typeface="Calibri" charset="0"/>
+                        <a:cs typeface="Calibri" charset="0"/>
+                      </a:endParaRPr>
+                    </a:p>
+                  </a:txBody>
+                  <a:tcPr marL="63500" marR="63500" marT="63500" marB="63500" anchor="ctr">
+                    <a:lnL w="12700" cap="flat" cmpd="sng" algn="ctr">
+                      <a:solidFill>
+                        <a:srgbClr val="2A2F3E"/>
+                      </a:solidFill>
+                      <a:prstDash val="solid"/>
+                      <a:round/>
+                      <a:headEnd type="none" w="med" len="med"/>
+                      <a:tailEnd type="none" w="med" len="med"/>
+                    </a:lnL>
+                    <a:lnR w="12700" cap="flat" cmpd="sng" algn="ctr">
+                      <a:solidFill>
+                        <a:srgbClr val="2A2F3E"/>
+                      </a:solidFill>
+                      <a:prstDash val="solid"/>
+                      <a:round/>
+                      <a:headEnd type="none" w="med" len="med"/>
+                      <a:tailEnd type="none" w="med" len="med"/>
+                    </a:lnR>
+                    <a:lnT w="12700" cap="flat" cmpd="sng" algn="ctr">
+                      <a:solidFill>
+                        <a:srgbClr val="2A2F3E"/>
+                      </a:solidFill>
+                      <a:prstDash val="solid"/>
+                      <a:round/>
+                      <a:headEnd type="none" w="med" len="med"/>
+                      <a:tailEnd type="none" w="med" len="med"/>
+                    </a:lnT>
+                    <a:lnB w="12700" cap="flat" cmpd="sng" algn="ctr">
+                      <a:solidFill>
+                        <a:srgbClr val="2A2F3E"/>
+                      </a:solidFill>
+                      <a:prstDash val="solid"/>
+                      <a:round/>
+                      <a:headEnd type="none" w="med" len="med"/>
+                      <a:tailEnd type="none" w="med" len="med"/>
+                    </a:lnB>
+                    <a:solidFill>
+                      <a:srgbClr val="1A1D27"/>
+                    </a:solidFill>
+                  </a:tcPr>
+                </a:tc>
+                <a:tc>
+                  <a:txBody>
+                    <a:bodyPr/>
+                    <a:lstStyle/>
+                    <a:p>
+                      <a:pPr algn="ctr" indent="0" marL="0">
+                        <a:buNone/>
+                      </a:pPr>
+                      <a:r>
+                        <a:rPr lang="en-US" sz="1200" b="1" dirty="0">
+                          <a:solidFill>
+                            <a:srgbClr val="5BC8AF"/>
+                          </a:solidFill>
+                          <a:latin typeface="Calibri" pitchFamily="34" charset="0"/>
+                          <a:ea typeface="Calibri" pitchFamily="34" charset="-122"/>
+                          <a:cs typeface="Calibri" pitchFamily="34" charset="-120"/>
+                        </a:rPr>
+                        <a:t>✓ Pass</a:t>
+                      </a:r>
+                      <a:endParaRPr lang="en-US" sz="1200" dirty="0">
+                        <a:latin typeface="Calibri" charset="0"/>
+                        <a:ea typeface="Calibri" charset="0"/>
+                        <a:cs typeface="Calibri" charset="0"/>
+                      </a:endParaRPr>
+                    </a:p>
+                  </a:txBody>
+                  <a:tcPr marL="63500" marR="63500" marT="63500" marB="63500" anchor="ctr">
+                    <a:lnL w="12700" cap="flat" cmpd="sng" algn="ctr">
+                      <a:solidFill>
+                        <a:srgbClr val="2A2F3E"/>
+                      </a:solidFill>
+                      <a:prstDash val="solid"/>
+                      <a:round/>
+                      <a:headEnd type="none" w="med" len="med"/>
+                      <a:tailEnd type="none" w="med" len="med"/>
+                    </a:lnL>
+                    <a:lnR w="12700" cap="flat" cmpd="sng" algn="ctr">
+                      <a:solidFill>
+                        <a:srgbClr val="2A2F3E"/>
+                      </a:solidFill>
+                      <a:prstDash val="solid"/>
+                      <a:round/>
+                      <a:headEnd type="none" w="med" len="med"/>
+                      <a:tailEnd type="none" w="med" len="med"/>
+                    </a:lnR>
+                    <a:lnT w="12700" cap="flat" cmpd="sng" algn="ctr">
+                      <a:solidFill>
+                        <a:srgbClr val="2A2F3E"/>
+                      </a:solidFill>
+                      <a:prstDash val="solid"/>
+                      <a:round/>
+                      <a:headEnd type="none" w="med" len="med"/>
+                      <a:tailEnd type="none" w="med" len="med"/>
+                    </a:lnT>
+                    <a:lnB w="12700" cap="flat" cmpd="sng" algn="ctr">
+                      <a:solidFill>
+                        <a:srgbClr val="2A2F3E"/>
+                      </a:solidFill>
+                      <a:prstDash val="solid"/>
+                      <a:round/>
+                      <a:headEnd type="none" w="med" len="med"/>
+                      <a:tailEnd type="none" w="med" len="med"/>
+                    </a:lnB>
+                    <a:solidFill>
+                      <a:srgbClr val="1A1D27"/>
+                    </a:solidFill>
+                  </a:tcPr>
+                </a:tc>
+              </a:tr>
+              <a:tr h="420624">
+                <a:tc>
+                  <a:txBody>
+                    <a:bodyPr/>
+                    <a:lstStyle/>
+                    <a:p>
+                      <a:pPr indent="0" marL="0">
+                        <a:buNone/>
+                      </a:pPr>
+                      <a:r>
+                        <a:rPr lang="en-US" sz="1200" dirty="0">
+                          <a:solidFill>
+                            <a:srgbClr val="ECECF3"/>
+                          </a:solidFill>
+                          <a:latin typeface="Calibri" pitchFamily="34" charset="0"/>
+                          <a:ea typeface="Calibri" pitchFamily="34" charset="-122"/>
+                          <a:cs typeface="Calibri" pitchFamily="34" charset="-120"/>
+                        </a:rPr>
+                        <a:t>"thoughtful sci-fi, alone"</a:t>
+                      </a:r>
+                      <a:endParaRPr lang="en-US" sz="1200" dirty="0">
+                        <a:latin typeface="Calibri" charset="0"/>
+                        <a:ea typeface="Calibri" charset="0"/>
+                        <a:cs typeface="Calibri" charset="0"/>
+                      </a:endParaRPr>
+                    </a:p>
+                  </a:txBody>
+                  <a:tcPr marL="63500" marR="63500" marT="63500" marB="63500" anchor="ctr">
+                    <a:lnL w="12700" cap="flat" cmpd="sng" algn="ctr">
+                      <a:solidFill>
+                        <a:srgbClr val="2A2F3E"/>
+                      </a:solidFill>
+                      <a:prstDash val="solid"/>
+                      <a:round/>
+                      <a:headEnd type="none" w="med" len="med"/>
+                      <a:tailEnd type="none" w="med" len="med"/>
+                    </a:lnL>
+                    <a:lnR w="12700" cap="flat" cmpd="sng" algn="ctr">
+                      <a:solidFill>
+                        <a:srgbClr val="2A2F3E"/>
+                      </a:solidFill>
+                      <a:prstDash val="solid"/>
+                      <a:round/>
+                      <a:headEnd type="none" w="med" len="med"/>
+                      <a:tailEnd type="none" w="med" len="med"/>
+                    </a:lnR>
+                    <a:lnT w="12700" cap="flat" cmpd="sng" algn="ctr">
+                      <a:solidFill>
+                        <a:srgbClr val="2A2F3E"/>
+                      </a:solidFill>
+                      <a:prstDash val="solid"/>
+                      <a:round/>
+                      <a:headEnd type="none" w="med" len="med"/>
+                      <a:tailEnd type="none" w="med" len="med"/>
+                    </a:lnT>
+                    <a:lnB w="12700" cap="flat" cmpd="sng" algn="ctr">
+                      <a:solidFill>
+                        <a:srgbClr val="2A2F3E"/>
+                      </a:solidFill>
+                      <a:prstDash val="solid"/>
+                      <a:round/>
+                      <a:headEnd type="none" w="med" len="med"/>
+                      <a:tailEnd type="none" w="med" len="med"/>
+                    </a:lnB>
+                    <a:solidFill>
+                      <a:srgbClr val="1A1D27"/>
+                    </a:solidFill>
+                  </a:tcPr>
+                </a:tc>
+                <a:tc>
+                  <a:txBody>
+                    <a:bodyPr/>
+                    <a:lstStyle/>
+                    <a:p>
+                      <a:pPr indent="0" marL="0">
+                        <a:buNone/>
+                      </a:pPr>
+                      <a:r>
+                        <a:rPr lang="en-US" sz="1200" dirty="0">
+                          <a:solidFill>
+                            <a:srgbClr val="ECECF3"/>
+                          </a:solidFill>
+                          <a:latin typeface="Calibri" pitchFamily="34" charset="0"/>
+                          <a:ea typeface="Calibri" pitchFamily="34" charset="-122"/>
+                          <a:cs typeface="Calibri" pitchFamily="34" charset="-120"/>
+                        </a:rPr>
+                        <a:t>Sci-Fi · deep · solo</a:t>
+                      </a:r>
+                      <a:endParaRPr lang="en-US" sz="1200" dirty="0">
+                        <a:latin typeface="Calibri" charset="0"/>
+                        <a:ea typeface="Calibri" charset="0"/>
+                        <a:cs typeface="Calibri" charset="0"/>
+                      </a:endParaRPr>
+                    </a:p>
+                  </a:txBody>
+                  <a:tcPr marL="63500" marR="63500" marT="63500" marB="63500" anchor="ctr">
+                    <a:lnL w="12700" cap="flat" cmpd="sng" algn="ctr">
+                      <a:solidFill>
+                        <a:srgbClr val="2A2F3E"/>
+                      </a:solidFill>
+                      <a:prstDash val="solid"/>
+                      <a:round/>
+                      <a:headEnd type="none" w="med" len="med"/>
+                      <a:tailEnd type="none" w="med" len="med"/>
+                    </a:lnL>
+                    <a:lnR w="12700" cap="flat" cmpd="sng" algn="ctr">
+                      <a:solidFill>
+                        <a:srgbClr val="2A2F3E"/>
+                      </a:solidFill>
+                      <a:prstDash val="solid"/>
+                      <a:round/>
+                      <a:headEnd type="none" w="med" len="med"/>
+                      <a:tailEnd type="none" w="med" len="med"/>
+                    </a:lnR>
+                    <a:lnT w="12700" cap="flat" cmpd="sng" algn="ctr">
+                      <a:solidFill>
+                        <a:srgbClr val="2A2F3E"/>
+                      </a:solidFill>
+                      <a:prstDash val="solid"/>
+                      <a:round/>
+                      <a:headEnd type="none" w="med" len="med"/>
+                      <a:tailEnd type="none" w="med" len="med"/>
+                    </a:lnT>
+                    <a:lnB w="12700" cap="flat" cmpd="sng" algn="ctr">
+                      <a:solidFill>
+                        <a:srgbClr val="2A2F3E"/>
+                      </a:solidFill>
+                      <a:prstDash val="solid"/>
+                      <a:round/>
+                      <a:headEnd type="none" w="med" len="med"/>
+                      <a:tailEnd type="none" w="med" len="med"/>
+                    </a:lnB>
+                    <a:solidFill>
+                      <a:srgbClr val="1A1D27"/>
+                    </a:solidFill>
+                  </a:tcPr>
+                </a:tc>
+                <a:tc>
+                  <a:txBody>
+                    <a:bodyPr/>
+                    <a:lstStyle/>
+                    <a:p>
+                      <a:pPr indent="0" marL="0">
+                        <a:buNone/>
+                      </a:pPr>
+                      <a:r>
+                        <a:rPr lang="en-US" sz="1200" dirty="0">
+                          <a:solidFill>
+                            <a:srgbClr val="ECECF3"/>
+                          </a:solidFill>
+                          <a:latin typeface="Calibri" pitchFamily="34" charset="0"/>
+                          <a:ea typeface="Calibri" pitchFamily="34" charset="-122"/>
+                          <a:cs typeface="Calibri" pitchFamily="34" charset="-120"/>
+                        </a:rPr>
+                        <a:t>🎬 Arrival (2016)</a:t>
+                      </a:r>
+                      <a:endParaRPr lang="en-US" sz="1200" dirty="0">
+                        <a:latin typeface="Calibri" charset="0"/>
+                        <a:ea typeface="Calibri" charset="0"/>
+                        <a:cs typeface="Calibri" charset="0"/>
+                      </a:endParaRPr>
+                    </a:p>
+                  </a:txBody>
+                  <a:tcPr marL="63500" marR="63500" marT="63500" marB="63500" anchor="ctr">
+                    <a:lnL w="12700" cap="flat" cmpd="sng" algn="ctr">
+                      <a:solidFill>
+                        <a:srgbClr val="2A2F3E"/>
+                      </a:solidFill>
+                      <a:prstDash val="solid"/>
+                      <a:round/>
+                      <a:headEnd type="none" w="med" len="med"/>
+                      <a:tailEnd type="none" w="med" len="med"/>
+                    </a:lnL>
+                    <a:lnR w="12700" cap="flat" cmpd="sng" algn="ctr">
+                      <a:solidFill>
+                        <a:srgbClr val="2A2F3E"/>
+                      </a:solidFill>
+                      <a:prstDash val="solid"/>
+                      <a:round/>
+                      <a:headEnd type="none" w="med" len="med"/>
+                      <a:tailEnd type="none" w="med" len="med"/>
+                    </a:lnR>
+                    <a:lnT w="12700" cap="flat" cmpd="sng" algn="ctr">
+                      <a:solidFill>
+                        <a:srgbClr val="2A2F3E"/>
+                      </a:solidFill>
+                      <a:prstDash val="solid"/>
+                      <a:round/>
+                      <a:headEnd type="none" w="med" len="med"/>
+                      <a:tailEnd type="none" w="med" len="med"/>
+                    </a:lnT>
+                    <a:lnB w="12700" cap="flat" cmpd="sng" algn="ctr">
+                      <a:solidFill>
+                        <a:srgbClr val="2A2F3E"/>
+                      </a:solidFill>
+                      <a:prstDash val="solid"/>
+                      <a:round/>
+                      <a:headEnd type="none" w="med" len="med"/>
+                      <a:tailEnd type="none" w="med" len="med"/>
+                    </a:lnB>
+                    <a:solidFill>
+                      <a:srgbClr val="1A1D27"/>
+                    </a:solidFill>
+                  </a:tcPr>
+                </a:tc>
+                <a:tc>
+                  <a:txBody>
+                    <a:bodyPr/>
+                    <a:lstStyle/>
+                    <a:p>
+                      <a:pPr algn="ctr" indent="0" marL="0">
+                        <a:buNone/>
+                      </a:pPr>
+                      <a:r>
+                        <a:rPr lang="en-US" sz="1200" b="1" dirty="0">
+                          <a:solidFill>
+                            <a:srgbClr val="5BC8AF"/>
+                          </a:solidFill>
+                          <a:latin typeface="Calibri" pitchFamily="34" charset="0"/>
+                          <a:ea typeface="Calibri" pitchFamily="34" charset="-122"/>
+                          <a:cs typeface="Calibri" pitchFamily="34" charset="-120"/>
+                        </a:rPr>
+                        <a:t>✓ Pass</a:t>
+                      </a:r>
+                      <a:endParaRPr lang="en-US" sz="1200" dirty="0">
+                        <a:latin typeface="Calibri" charset="0"/>
+                        <a:ea typeface="Calibri" charset="0"/>
+                        <a:cs typeface="Calibri" charset="0"/>
+                      </a:endParaRPr>
+                    </a:p>
+                  </a:txBody>
+                  <a:tcPr marL="63500" marR="63500" marT="63500" marB="63500" anchor="ctr">
+                    <a:lnL w="12700" cap="flat" cmpd="sng" algn="ctr">
+                      <a:solidFill>
+                        <a:srgbClr val="2A2F3E"/>
+                      </a:solidFill>
+                      <a:prstDash val="solid"/>
+                      <a:round/>
+                      <a:headEnd type="none" w="med" len="med"/>
+                      <a:tailEnd type="none" w="med" len="med"/>
+                    </a:lnL>
+                    <a:lnR w="12700" cap="flat" cmpd="sng" algn="ctr">
+                      <a:solidFill>
+                        <a:srgbClr val="2A2F3E"/>
+                      </a:solidFill>
+                      <a:prstDash val="solid"/>
+                      <a:round/>
+                      <a:headEnd type="none" w="med" len="med"/>
+                      <a:tailEnd type="none" w="med" len="med"/>
+                    </a:lnR>
+                    <a:lnT w="12700" cap="flat" cmpd="sng" algn="ctr">
+                      <a:solidFill>
+                        <a:srgbClr val="2A2F3E"/>
+                      </a:solidFill>
+                      <a:prstDash val="solid"/>
+                      <a:round/>
+                      <a:headEnd type="none" w="med" len="med"/>
+                      <a:tailEnd type="none" w="med" len="med"/>
+                    </a:lnT>
+                    <a:lnB w="12700" cap="flat" cmpd="sng" algn="ctr">
+                      <a:solidFill>
+                        <a:srgbClr val="2A2F3E"/>
+                      </a:solidFill>
+                      <a:prstDash val="solid"/>
+                      <a:round/>
+                      <a:headEnd type="none" w="med" len="med"/>
+                      <a:tailEnd type="none" w="med" len="med"/>
+                    </a:lnB>
+                    <a:solidFill>
+                      <a:srgbClr val="1A1D27"/>
+                    </a:solidFill>
+                  </a:tcPr>
+                </a:tc>
+              </a:tr>
+            </a:tbl>
+          </a:graphicData>
+        </a:graphic>
+      </p:graphicFrame>
+      <p:sp>
+        <p:nvSpPr>
+          <p:cNvPr id="6" name="Text 3"/>
+          <p:cNvSpPr/>
+          <p:nvPr/>
+        </p:nvSpPr>
+        <p:spPr>
+          <a:xfrm>
+            <a:off x="640080" y="4297680"/>
+            <a:ext cx="7315200" cy="365760"/>
+          </a:xfrm>
+          <a:prstGeom prst="rect">
+            <a:avLst/>
+          </a:prstGeom>
+          <a:noFill/>
+          <a:ln/>
+        </p:spPr>
+        <p:txBody>
+          <a:bodyPr wrap="square" lIns="0" tIns="0" rIns="0" bIns="0" rtlCol="0" anchor="ctr"/>
+          <a:lstStyle/>
+          <a:p>
+            <a:pPr indent="0" marL="0">
+              <a:buNone/>
+            </a:pPr>
+            <a:r>
+              <a:rPr lang="en-US" sz="1500" b="1" dirty="0">
+                <a:solidFill>
+                  <a:srgbClr val="FFB347"/>
+                </a:solidFill>
+                <a:latin typeface="Calibri" pitchFamily="34" charset="0"/>
+                <a:ea typeface="Calibri" pitchFamily="34" charset="-122"/>
+                <a:cs typeface="Calibri" pitchFamily="34" charset="-120"/>
+              </a:rPr>
+              <a:t>Edge cases handled</a:t>
+            </a:r>
+            <a:endParaRPr lang="en-US" sz="1500" dirty="0"/>
+          </a:p>
+        </p:txBody>
+      </p:sp>
+      <p:sp>
+        <p:nvSpPr>
+          <p:cNvPr id="7" name="Shape 4"/>
+          <p:cNvSpPr/>
+          <p:nvPr/>
+        </p:nvSpPr>
+        <p:spPr>
+          <a:xfrm>
+            <a:off x="640080" y="4663440"/>
+            <a:ext cx="2446020" cy="1417320"/>
           </a:xfrm>
           <a:prstGeom prst="roundRect">
             <a:avLst>
-              <a:gd name="adj" fmla="val 4706"/>
+              <a:gd name="adj" fmla="val 5161"/>
             </a:avLst>
           </a:prstGeom>
           <a:solidFill>
@@ -6729,34 +8348,14 @@
       </p:sp>
       <p:sp>
         <p:nvSpPr>
-          <p:cNvPr id="6" name="Shape 4"/>
-          <p:cNvSpPr/>
-          <p:nvPr/>
-        </p:nvSpPr>
-        <p:spPr>
-          <a:xfrm>
-            <a:off x="640080" y="2103120"/>
-            <a:ext cx="2446020" cy="82296"/>
-          </a:xfrm>
-          <a:prstGeom prst="rect">
-            <a:avLst/>
-          </a:prstGeom>
-          <a:solidFill>
-            <a:srgbClr val="FFB347"/>
-          </a:solidFill>
-          <a:ln/>
-        </p:spPr>
-      </p:sp>
-      <p:sp>
-        <p:nvSpPr>
-          <p:cNvPr id="7" name="Text 5"/>
-          <p:cNvSpPr/>
-          <p:nvPr/>
-        </p:nvSpPr>
-        <p:spPr>
-          <a:xfrm>
-            <a:off x="822960" y="2423160"/>
-            <a:ext cx="2080260" cy="365760"/>
+          <p:cNvPr id="8" name="Text 5"/>
+          <p:cNvSpPr/>
+          <p:nvPr/>
+        </p:nvSpPr>
+        <p:spPr>
+          <a:xfrm>
+            <a:off x="841248" y="4828032"/>
+            <a:ext cx="548640" cy="457200"/>
           </a:xfrm>
           <a:prstGeom prst="rect">
             <a:avLst/>
@@ -6772,7 +8371,85 @@
               <a:buNone/>
             </a:pPr>
             <a:r>
-              <a:rPr lang="en-US" sz="1100" b="1" spc="100" kern="0" dirty="0">
+              <a:rPr lang="en-US" sz="2000" dirty="0">
+                <a:solidFill>
+                  <a:srgbClr val="000000"/>
+                </a:solidFill>
+              </a:rPr>
+              <a:t>🎭</a:t>
+            </a:r>
+            <a:endParaRPr lang="en-US" sz="2000" dirty="0"/>
+          </a:p>
+        </p:txBody>
+      </p:sp>
+      <p:sp>
+        <p:nvSpPr>
+          <p:cNvPr id="9" name="Text 6"/>
+          <p:cNvSpPr/>
+          <p:nvPr/>
+        </p:nvSpPr>
+        <p:spPr>
+          <a:xfrm>
+            <a:off x="1353312" y="4846320"/>
+            <a:ext cx="1577340" cy="365760"/>
+          </a:xfrm>
+          <a:prstGeom prst="rect">
+            <a:avLst/>
+          </a:prstGeom>
+          <a:noFill/>
+          <a:ln/>
+        </p:spPr>
+        <p:txBody>
+          <a:bodyPr wrap="square" lIns="0" tIns="0" rIns="0" bIns="0" rtlCol="0" anchor="ctr"/>
+          <a:lstStyle/>
+          <a:p>
+            <a:pPr indent="0" marL="0">
+              <a:buNone/>
+            </a:pPr>
+            <a:r>
+              <a:rPr lang="en-US" sz="1350" b="1" dirty="0">
+                <a:solidFill>
+                  <a:srgbClr val="ECECF3"/>
+                </a:solidFill>
+                <a:latin typeface="Calibri" pitchFamily="34" charset="0"/>
+                <a:ea typeface="Calibri" pitchFamily="34" charset="-122"/>
+                <a:cs typeface="Calibri" pitchFamily="34" charset="-120"/>
+              </a:rPr>
+              <a:t>Mixed mood</a:t>
+            </a:r>
+            <a:endParaRPr lang="en-US" sz="1350" dirty="0"/>
+          </a:p>
+        </p:txBody>
+      </p:sp>
+      <p:sp>
+        <p:nvSpPr>
+          <p:cNvPr id="10" name="Text 7"/>
+          <p:cNvSpPr/>
+          <p:nvPr/>
+        </p:nvSpPr>
+        <p:spPr>
+          <a:xfrm>
+            <a:off x="841248" y="5321808"/>
+            <a:ext cx="2043684" cy="713232"/>
+          </a:xfrm>
+          <a:prstGeom prst="rect">
+            <a:avLst/>
+          </a:prstGeom>
+          <a:noFill/>
+          <a:ln/>
+        </p:spPr>
+        <p:txBody>
+          <a:bodyPr wrap="square" lIns="0" tIns="0" rIns="0" bIns="0" rtlCol="0" anchor="ctr"/>
+          <a:lstStyle/>
+          <a:p>
+            <a:pPr indent="0" marL="0">
+              <a:lnSpc>
+                <a:spcPct val="108000"/>
+              </a:lnSpc>
+              <a:buNone/>
+            </a:pPr>
+            <a:r>
+              <a:rPr lang="en-US" sz="1050" dirty="0">
                 <a:solidFill>
                   <a:srgbClr val="9AA0B4"/>
                 </a:solidFill>
@@ -6780,65 +8457,26 @@
                 <a:ea typeface="Calibri" pitchFamily="34" charset="-122"/>
                 <a:cs typeface="Calibri" pitchFamily="34" charset="-120"/>
               </a:rPr>
-              <a:t>ENGINE</a:t>
-            </a:r>
-            <a:endParaRPr lang="en-US" sz="1100" dirty="0"/>
-          </a:p>
-        </p:txBody>
-      </p:sp>
-      <p:sp>
-        <p:nvSpPr>
-          <p:cNvPr id="8" name="Text 6"/>
-          <p:cNvSpPr/>
-          <p:nvPr/>
-        </p:nvSpPr>
-        <p:spPr>
-          <a:xfrm>
-            <a:off x="822960" y="2834640"/>
-            <a:ext cx="2080260" cy="640080"/>
-          </a:xfrm>
-          <a:prstGeom prst="rect">
-            <a:avLst/>
-          </a:prstGeom>
-          <a:noFill/>
-          <a:ln/>
-        </p:spPr>
-        <p:txBody>
-          <a:bodyPr wrap="square" lIns="0" tIns="0" rIns="0" bIns="0" rtlCol="0" anchor="ctr"/>
-          <a:lstStyle/>
-          <a:p>
-            <a:pPr indent="0" marL="0">
-              <a:buNone/>
-            </a:pPr>
-            <a:r>
-              <a:rPr lang="en-US" sz="1500" b="1" dirty="0">
-                <a:solidFill>
-                  <a:srgbClr val="ECECF3"/>
-                </a:solidFill>
-                <a:latin typeface="Calibri" pitchFamily="34" charset="0"/>
-                <a:ea typeface="Calibri" pitchFamily="34" charset="-122"/>
-                <a:cs typeface="Calibri" pitchFamily="34" charset="-120"/>
-              </a:rPr>
-              <a:t>C → cinematch.exe</a:t>
-            </a:r>
-            <a:endParaRPr lang="en-US" sz="1500" dirty="0"/>
-          </a:p>
-        </p:txBody>
-      </p:sp>
-      <p:sp>
-        <p:nvSpPr>
-          <p:cNvPr id="9" name="Shape 7"/>
-          <p:cNvSpPr/>
-          <p:nvPr/>
-        </p:nvSpPr>
-        <p:spPr>
-          <a:xfrm>
-            <a:off x="3451860" y="2103120"/>
-            <a:ext cx="2446020" cy="1554480"/>
+              <a:t>“happy but tense” → the AI picks the dominant signal; a valid pick still returns.</a:t>
+            </a:r>
+            <a:endParaRPr lang="en-US" sz="1050" dirty="0"/>
+          </a:p>
+        </p:txBody>
+      </p:sp>
+      <p:sp>
+        <p:nvSpPr>
+          <p:cNvPr id="11" name="Shape 8"/>
+          <p:cNvSpPr/>
+          <p:nvPr/>
+        </p:nvSpPr>
+        <p:spPr>
+          <a:xfrm>
+            <a:off x="3451860" y="4663440"/>
+            <a:ext cx="2446020" cy="1417320"/>
           </a:xfrm>
           <a:prstGeom prst="roundRect">
             <a:avLst>
-              <a:gd name="adj" fmla="val 4706"/>
+              <a:gd name="adj" fmla="val 5161"/>
             </a:avLst>
           </a:prstGeom>
           <a:solidFill>
@@ -6861,34 +8499,14 @@
       </p:sp>
       <p:sp>
         <p:nvSpPr>
-          <p:cNvPr id="10" name="Shape 8"/>
-          <p:cNvSpPr/>
-          <p:nvPr/>
-        </p:nvSpPr>
-        <p:spPr>
-          <a:xfrm>
-            <a:off x="3451860" y="2103120"/>
-            <a:ext cx="2446020" cy="82296"/>
-          </a:xfrm>
-          <a:prstGeom prst="rect">
-            <a:avLst/>
-          </a:prstGeom>
-          <a:solidFill>
-            <a:srgbClr val="FFB347"/>
-          </a:solidFill>
-          <a:ln/>
-        </p:spPr>
-      </p:sp>
-      <p:sp>
-        <p:nvSpPr>
-          <p:cNvPr id="11" name="Text 9"/>
-          <p:cNvSpPr/>
-          <p:nvPr/>
-        </p:nvSpPr>
-        <p:spPr>
-          <a:xfrm>
-            <a:off x="3634740" y="2423160"/>
-            <a:ext cx="2080260" cy="365760"/>
+          <p:cNvPr id="12" name="Text 9"/>
+          <p:cNvSpPr/>
+          <p:nvPr/>
+        </p:nvSpPr>
+        <p:spPr>
+          <a:xfrm>
+            <a:off x="3653028" y="4828032"/>
+            <a:ext cx="548640" cy="457200"/>
           </a:xfrm>
           <a:prstGeom prst="rect">
             <a:avLst/>
@@ -6904,7 +8522,85 @@
               <a:buNone/>
             </a:pPr>
             <a:r>
-              <a:rPr lang="en-US" sz="1100" b="1" spc="100" kern="0" dirty="0">
+              <a:rPr lang="en-US" sz="2000" dirty="0">
+                <a:solidFill>
+                  <a:srgbClr val="000000"/>
+                </a:solidFill>
+              </a:rPr>
+              <a:t>⚡</a:t>
+            </a:r>
+            <a:endParaRPr lang="en-US" sz="2000" dirty="0"/>
+          </a:p>
+        </p:txBody>
+      </p:sp>
+      <p:sp>
+        <p:nvSpPr>
+          <p:cNvPr id="13" name="Text 10"/>
+          <p:cNvSpPr/>
+          <p:nvPr/>
+        </p:nvSpPr>
+        <p:spPr>
+          <a:xfrm>
+            <a:off x="4165092" y="4846320"/>
+            <a:ext cx="1577340" cy="365760"/>
+          </a:xfrm>
+          <a:prstGeom prst="rect">
+            <a:avLst/>
+          </a:prstGeom>
+          <a:noFill/>
+          <a:ln/>
+        </p:spPr>
+        <p:txBody>
+          <a:bodyPr wrap="square" lIns="0" tIns="0" rIns="0" bIns="0" rtlCol="0" anchor="ctr"/>
+          <a:lstStyle/>
+          <a:p>
+            <a:pPr indent="0" marL="0">
+              <a:buNone/>
+            </a:pPr>
+            <a:r>
+              <a:rPr lang="en-US" sz="1350" b="1" dirty="0">
+                <a:solidFill>
+                  <a:srgbClr val="ECECF3"/>
+                </a:solidFill>
+                <a:latin typeface="Calibri" pitchFamily="34" charset="0"/>
+                <a:ea typeface="Calibri" pitchFamily="34" charset="-122"/>
+                <a:cs typeface="Calibri" pitchFamily="34" charset="-120"/>
+              </a:rPr>
+              <a:t>AI failure</a:t>
+            </a:r>
+            <a:endParaRPr lang="en-US" sz="1350" dirty="0"/>
+          </a:p>
+        </p:txBody>
+      </p:sp>
+      <p:sp>
+        <p:nvSpPr>
+          <p:cNvPr id="14" name="Text 11"/>
+          <p:cNvSpPr/>
+          <p:nvPr/>
+        </p:nvSpPr>
+        <p:spPr>
+          <a:xfrm>
+            <a:off x="3653028" y="5321808"/>
+            <a:ext cx="2043684" cy="713232"/>
+          </a:xfrm>
+          <a:prstGeom prst="rect">
+            <a:avLst/>
+          </a:prstGeom>
+          <a:noFill/>
+          <a:ln/>
+        </p:spPr>
+        <p:txBody>
+          <a:bodyPr wrap="square" lIns="0" tIns="0" rIns="0" bIns="0" rtlCol="0" anchor="ctr"/>
+          <a:lstStyle/>
+          <a:p>
+            <a:pPr indent="0" marL="0">
+              <a:lnSpc>
+                <a:spcPct val="108000"/>
+              </a:lnSpc>
+              <a:buNone/>
+            </a:pPr>
+            <a:r>
+              <a:rPr lang="en-US" sz="1050" dirty="0">
                 <a:solidFill>
                   <a:srgbClr val="9AA0B4"/>
                 </a:solidFill>
@@ -6912,65 +8608,26 @@
                 <a:ea typeface="Calibri" pitchFamily="34" charset="-122"/>
                 <a:cs typeface="Calibri" pitchFamily="34" charset="-120"/>
               </a:rPr>
-              <a:t>BACKEND</a:t>
-            </a:r>
-            <a:endParaRPr lang="en-US" sz="1100" dirty="0"/>
-          </a:p>
-        </p:txBody>
-      </p:sp>
-      <p:sp>
-        <p:nvSpPr>
-          <p:cNvPr id="12" name="Text 10"/>
-          <p:cNvSpPr/>
-          <p:nvPr/>
-        </p:nvSpPr>
-        <p:spPr>
-          <a:xfrm>
-            <a:off x="3634740" y="2834640"/>
-            <a:ext cx="2080260" cy="640080"/>
-          </a:xfrm>
-          <a:prstGeom prst="rect">
-            <a:avLst/>
-          </a:prstGeom>
-          <a:noFill/>
-          <a:ln/>
-        </p:spPr>
-        <p:txBody>
-          <a:bodyPr wrap="square" lIns="0" tIns="0" rIns="0" bIns="0" rtlCol="0" anchor="ctr"/>
-          <a:lstStyle/>
-          <a:p>
-            <a:pPr indent="0" marL="0">
-              <a:buNone/>
-            </a:pPr>
-            <a:r>
-              <a:rPr lang="en-US" sz="1500" b="1" dirty="0">
-                <a:solidFill>
-                  <a:srgbClr val="ECECF3"/>
-                </a:solidFill>
-                <a:latin typeface="Calibri" pitchFamily="34" charset="0"/>
-                <a:ea typeface="Calibri" pitchFamily="34" charset="-122"/>
-                <a:cs typeface="Calibri" pitchFamily="34" charset="-120"/>
-              </a:rPr>
-              <a:t>Node.js + Express</a:t>
-            </a:r>
-            <a:endParaRPr lang="en-US" sz="1500" dirty="0"/>
-          </a:p>
-        </p:txBody>
-      </p:sp>
-      <p:sp>
-        <p:nvSpPr>
-          <p:cNvPr id="13" name="Shape 11"/>
-          <p:cNvSpPr/>
-          <p:nvPr/>
-        </p:nvSpPr>
-        <p:spPr>
-          <a:xfrm>
-            <a:off x="6263640" y="2103120"/>
-            <a:ext cx="2446020" cy="1554480"/>
+              <a:t>Rate-limit or error → keyword fallback derives preferences. Never crashes.</a:t>
+            </a:r>
+            <a:endParaRPr lang="en-US" sz="1050" dirty="0"/>
+          </a:p>
+        </p:txBody>
+      </p:sp>
+      <p:sp>
+        <p:nvSpPr>
+          <p:cNvPr id="15" name="Shape 12"/>
+          <p:cNvSpPr/>
+          <p:nvPr/>
+        </p:nvSpPr>
+        <p:spPr>
+          <a:xfrm>
+            <a:off x="6263640" y="4663440"/>
+            <a:ext cx="2446020" cy="1417320"/>
           </a:xfrm>
           <a:prstGeom prst="roundRect">
             <a:avLst>
-              <a:gd name="adj" fmla="val 4706"/>
+              <a:gd name="adj" fmla="val 5161"/>
             </a:avLst>
           </a:prstGeom>
           <a:solidFill>
@@ -6993,34 +8650,14 @@
       </p:sp>
       <p:sp>
         <p:nvSpPr>
-          <p:cNvPr id="14" name="Shape 12"/>
-          <p:cNvSpPr/>
-          <p:nvPr/>
-        </p:nvSpPr>
-        <p:spPr>
-          <a:xfrm>
-            <a:off x="6263640" y="2103120"/>
-            <a:ext cx="2446020" cy="82296"/>
-          </a:xfrm>
-          <a:prstGeom prst="rect">
-            <a:avLst/>
-          </a:prstGeom>
-          <a:solidFill>
-            <a:srgbClr val="FFB347"/>
-          </a:solidFill>
-          <a:ln/>
-        </p:spPr>
-      </p:sp>
-      <p:sp>
-        <p:nvSpPr>
-          <p:cNvPr id="15" name="Text 13"/>
-          <p:cNvSpPr/>
-          <p:nvPr/>
-        </p:nvSpPr>
-        <p:spPr>
-          <a:xfrm>
-            <a:off x="6446520" y="2423160"/>
-            <a:ext cx="2080260" cy="365760"/>
+          <p:cNvPr id="16" name="Text 13"/>
+          <p:cNvSpPr/>
+          <p:nvPr/>
+        </p:nvSpPr>
+        <p:spPr>
+          <a:xfrm>
+            <a:off x="6464808" y="4828032"/>
+            <a:ext cx="548640" cy="457200"/>
           </a:xfrm>
           <a:prstGeom prst="rect">
             <a:avLst/>
@@ -7036,7 +8673,85 @@
               <a:buNone/>
             </a:pPr>
             <a:r>
-              <a:rPr lang="en-US" sz="1100" b="1" spc="100" kern="0" dirty="0">
+              <a:rPr lang="en-US" sz="2000" dirty="0">
+                <a:solidFill>
+                  <a:srgbClr val="000000"/>
+                </a:solidFill>
+              </a:rPr>
+              <a:t>🚫</a:t>
+            </a:r>
+            <a:endParaRPr lang="en-US" sz="2000" dirty="0"/>
+          </a:p>
+        </p:txBody>
+      </p:sp>
+      <p:sp>
+        <p:nvSpPr>
+          <p:cNvPr id="17" name="Text 14"/>
+          <p:cNvSpPr/>
+          <p:nvPr/>
+        </p:nvSpPr>
+        <p:spPr>
+          <a:xfrm>
+            <a:off x="6976872" y="4846320"/>
+            <a:ext cx="1577340" cy="365760"/>
+          </a:xfrm>
+          <a:prstGeom prst="rect">
+            <a:avLst/>
+          </a:prstGeom>
+          <a:noFill/>
+          <a:ln/>
+        </p:spPr>
+        <p:txBody>
+          <a:bodyPr wrap="square" lIns="0" tIns="0" rIns="0" bIns="0" rtlCol="0" anchor="ctr"/>
+          <a:lstStyle/>
+          <a:p>
+            <a:pPr indent="0" marL="0">
+              <a:buNone/>
+            </a:pPr>
+            <a:r>
+              <a:rPr lang="en-US" sz="1350" b="1" dirty="0">
+                <a:solidFill>
+                  <a:srgbClr val="ECECF3"/>
+                </a:solidFill>
+                <a:latin typeface="Calibri" pitchFamily="34" charset="0"/>
+                <a:ea typeface="Calibri" pitchFamily="34" charset="-122"/>
+                <a:cs typeface="Calibri" pitchFamily="34" charset="-120"/>
+              </a:rPr>
+              <a:t>Empty input</a:t>
+            </a:r>
+            <a:endParaRPr lang="en-US" sz="1350" dirty="0"/>
+          </a:p>
+        </p:txBody>
+      </p:sp>
+      <p:sp>
+        <p:nvSpPr>
+          <p:cNvPr id="18" name="Text 15"/>
+          <p:cNvSpPr/>
+          <p:nvPr/>
+        </p:nvSpPr>
+        <p:spPr>
+          <a:xfrm>
+            <a:off x="6464808" y="5321808"/>
+            <a:ext cx="2043684" cy="713232"/>
+          </a:xfrm>
+          <a:prstGeom prst="rect">
+            <a:avLst/>
+          </a:prstGeom>
+          <a:noFill/>
+          <a:ln/>
+        </p:spPr>
+        <p:txBody>
+          <a:bodyPr wrap="square" lIns="0" tIns="0" rIns="0" bIns="0" rtlCol="0" anchor="ctr"/>
+          <a:lstStyle/>
+          <a:p>
+            <a:pPr indent="0" marL="0">
+              <a:lnSpc>
+                <a:spcPct val="108000"/>
+              </a:lnSpc>
+              <a:buNone/>
+            </a:pPr>
+            <a:r>
+              <a:rPr lang="en-US" sz="1050" dirty="0">
                 <a:solidFill>
                   <a:srgbClr val="9AA0B4"/>
                 </a:solidFill>
@@ -7044,65 +8759,26 @@
                 <a:ea typeface="Calibri" pitchFamily="34" charset="-122"/>
                 <a:cs typeface="Calibri" pitchFamily="34" charset="-120"/>
               </a:rPr>
-              <a:t>FRONTEND</a:t>
-            </a:r>
-            <a:endParaRPr lang="en-US" sz="1100" dirty="0"/>
-          </a:p>
-        </p:txBody>
-      </p:sp>
-      <p:sp>
-        <p:nvSpPr>
-          <p:cNvPr id="16" name="Text 14"/>
-          <p:cNvSpPr/>
-          <p:nvPr/>
-        </p:nvSpPr>
-        <p:spPr>
-          <a:xfrm>
-            <a:off x="6446520" y="2834640"/>
-            <a:ext cx="2080260" cy="640080"/>
-          </a:xfrm>
-          <a:prstGeom prst="rect">
-            <a:avLst/>
-          </a:prstGeom>
-          <a:noFill/>
-          <a:ln/>
-        </p:spPr>
-        <p:txBody>
-          <a:bodyPr wrap="square" lIns="0" tIns="0" rIns="0" bIns="0" rtlCol="0" anchor="ctr"/>
-          <a:lstStyle/>
-          <a:p>
-            <a:pPr indent="0" marL="0">
-              <a:buNone/>
-            </a:pPr>
-            <a:r>
-              <a:rPr lang="en-US" sz="1500" b="1" dirty="0">
-                <a:solidFill>
-                  <a:srgbClr val="ECECF3"/>
-                </a:solidFill>
-                <a:latin typeface="Calibri" pitchFamily="34" charset="0"/>
-                <a:ea typeface="Calibri" pitchFamily="34" charset="-122"/>
-                <a:cs typeface="Calibri" pitchFamily="34" charset="-120"/>
-              </a:rPr>
-              <a:t>Vite + React</a:t>
-            </a:r>
-            <a:endParaRPr lang="en-US" sz="1500" dirty="0"/>
-          </a:p>
-        </p:txBody>
-      </p:sp>
-      <p:sp>
-        <p:nvSpPr>
-          <p:cNvPr id="17" name="Shape 15"/>
-          <p:cNvSpPr/>
-          <p:nvPr/>
-        </p:nvSpPr>
-        <p:spPr>
-          <a:xfrm>
-            <a:off x="9075420" y="2103120"/>
-            <a:ext cx="2446020" cy="1554480"/>
+              <a:t>Blank text is rejected with a friendly message before any work runs.</a:t>
+            </a:r>
+            <a:endParaRPr lang="en-US" sz="1050" dirty="0"/>
+          </a:p>
+        </p:txBody>
+      </p:sp>
+      <p:sp>
+        <p:nvSpPr>
+          <p:cNvPr id="19" name="Shape 16"/>
+          <p:cNvSpPr/>
+          <p:nvPr/>
+        </p:nvSpPr>
+        <p:spPr>
+          <a:xfrm>
+            <a:off x="9075420" y="4663440"/>
+            <a:ext cx="2446020" cy="1417320"/>
           </a:xfrm>
           <a:prstGeom prst="roundRect">
             <a:avLst>
-              <a:gd name="adj" fmla="val 4706"/>
+              <a:gd name="adj" fmla="val 5161"/>
             </a:avLst>
           </a:prstGeom>
           <a:solidFill>
@@ -7125,16 +8801,257 @@
       </p:sp>
       <p:sp>
         <p:nvSpPr>
-          <p:cNvPr id="18" name="Shape 16"/>
-          <p:cNvSpPr/>
-          <p:nvPr/>
-        </p:nvSpPr>
-        <p:spPr>
-          <a:xfrm>
-            <a:off x="9075420" y="2103120"/>
-            <a:ext cx="2446020" cy="82296"/>
-          </a:xfrm>
-          <a:prstGeom prst="rect">
+          <p:cNvPr id="20" name="Text 17"/>
+          <p:cNvSpPr/>
+          <p:nvPr/>
+        </p:nvSpPr>
+        <p:spPr>
+          <a:xfrm>
+            <a:off x="9276588" y="4828032"/>
+            <a:ext cx="548640" cy="457200"/>
+          </a:xfrm>
+          <a:prstGeom prst="rect">
+            <a:avLst/>
+          </a:prstGeom>
+          <a:noFill/>
+          <a:ln/>
+        </p:spPr>
+        <p:txBody>
+          <a:bodyPr wrap="square" lIns="0" tIns="0" rIns="0" bIns="0" rtlCol="0" anchor="ctr"/>
+          <a:lstStyle/>
+          <a:p>
+            <a:pPr indent="0" marL="0">
+              <a:buNone/>
+            </a:pPr>
+            <a:r>
+              <a:rPr lang="en-US" sz="2000" dirty="0">
+                <a:solidFill>
+                  <a:srgbClr val="000000"/>
+                </a:solidFill>
+              </a:rPr>
+              <a:t>🔀</a:t>
+            </a:r>
+            <a:endParaRPr lang="en-US" sz="2000" dirty="0"/>
+          </a:p>
+        </p:txBody>
+      </p:sp>
+      <p:sp>
+        <p:nvSpPr>
+          <p:cNvPr id="21" name="Text 18"/>
+          <p:cNvSpPr/>
+          <p:nvPr/>
+        </p:nvSpPr>
+        <p:spPr>
+          <a:xfrm>
+            <a:off x="9788652" y="4846320"/>
+            <a:ext cx="1577340" cy="365760"/>
+          </a:xfrm>
+          <a:prstGeom prst="rect">
+            <a:avLst/>
+          </a:prstGeom>
+          <a:noFill/>
+          <a:ln/>
+        </p:spPr>
+        <p:txBody>
+          <a:bodyPr wrap="square" lIns="0" tIns="0" rIns="0" bIns="0" rtlCol="0" anchor="ctr"/>
+          <a:lstStyle/>
+          <a:p>
+            <a:pPr indent="0" marL="0">
+              <a:buNone/>
+            </a:pPr>
+            <a:r>
+              <a:rPr lang="en-US" sz="1350" b="1" dirty="0">
+                <a:solidFill>
+                  <a:srgbClr val="ECECF3"/>
+                </a:solidFill>
+                <a:latin typeface="Calibri" pitchFamily="34" charset="0"/>
+                <a:ea typeface="Calibri" pitchFamily="34" charset="-122"/>
+                <a:cs typeface="Calibri" pitchFamily="34" charset="-120"/>
+              </a:rPr>
+              <a:t>Gibberish</a:t>
+            </a:r>
+            <a:endParaRPr lang="en-US" sz="1350" dirty="0"/>
+          </a:p>
+        </p:txBody>
+      </p:sp>
+      <p:sp>
+        <p:nvSpPr>
+          <p:cNvPr id="22" name="Text 19"/>
+          <p:cNvSpPr/>
+          <p:nvPr/>
+        </p:nvSpPr>
+        <p:spPr>
+          <a:xfrm>
+            <a:off x="9276588" y="5321808"/>
+            <a:ext cx="2043684" cy="713232"/>
+          </a:xfrm>
+          <a:prstGeom prst="rect">
+            <a:avLst/>
+          </a:prstGeom>
+          <a:noFill/>
+          <a:ln/>
+        </p:spPr>
+        <p:txBody>
+          <a:bodyPr wrap="square" lIns="0" tIns="0" rIns="0" bIns="0" rtlCol="0" anchor="ctr"/>
+          <a:lstStyle/>
+          <a:p>
+            <a:pPr indent="0" marL="0">
+              <a:lnSpc>
+                <a:spcPct val="108000"/>
+              </a:lnSpc>
+              <a:buNone/>
+            </a:pPr>
+            <a:r>
+              <a:rPr lang="en-US" sz="1050" dirty="0">
+                <a:solidFill>
+                  <a:srgbClr val="9AA0B4"/>
+                </a:solidFill>
+                <a:latin typeface="Calibri" pitchFamily="34" charset="0"/>
+                <a:ea typeface="Calibri" pitchFamily="34" charset="-122"/>
+                <a:cs typeface="Calibri" pitchFamily="34" charset="-120"/>
+              </a:rPr>
+              <a:t>Unrecognised text falls back to safe default preferences — always a result.</a:t>
+            </a:r>
+            <a:endParaRPr lang="en-US" sz="1050" dirty="0"/>
+          </a:p>
+        </p:txBody>
+      </p:sp>
+      <p:sp>
+        <p:nvSpPr>
+          <p:cNvPr id="23" name="Text 20"/>
+          <p:cNvSpPr/>
+          <p:nvPr/>
+        </p:nvSpPr>
+        <p:spPr>
+          <a:xfrm>
+            <a:off x="640080" y="6400800"/>
+            <a:ext cx="8229600" cy="274320"/>
+          </a:xfrm>
+          <a:prstGeom prst="rect">
+            <a:avLst/>
+          </a:prstGeom>
+          <a:noFill/>
+          <a:ln/>
+        </p:spPr>
+        <p:txBody>
+          <a:bodyPr wrap="square" lIns="0" tIns="0" rIns="0" bIns="0" rtlCol="0" anchor="ctr"/>
+          <a:lstStyle/>
+          <a:p>
+            <a:pPr indent="0" marL="0">
+              <a:buNone/>
+            </a:pPr>
+            <a:r>
+              <a:rPr lang="en-US" sz="900" b="1" dirty="0">
+                <a:solidFill>
+                  <a:srgbClr val="FFB347"/>
+                </a:solidFill>
+                <a:latin typeface="Calibri" pitchFamily="34" charset="0"/>
+                <a:ea typeface="Calibri" pitchFamily="34" charset="-122"/>
+                <a:cs typeface="Calibri" pitchFamily="34" charset="-120"/>
+              </a:rPr>
+              <a:t>CINEMATCH</a:t>
+            </a:r>
+            <a:pPr indent="0" marL="0">
+              <a:buNone/>
+            </a:pPr>
+            <a:r>
+              <a:rPr lang="en-US" sz="900" dirty="0">
+                <a:solidFill>
+                  <a:srgbClr val="9AA0B4"/>
+                </a:solidFill>
+                <a:latin typeface="Calibri" pitchFamily="34" charset="0"/>
+                <a:ea typeface="Calibri" pitchFamily="34" charset="-122"/>
+                <a:cs typeface="Calibri" pitchFamily="34" charset="-120"/>
+              </a:rPr>
+              <a:t>   ·   AI-Powered Movie &amp; Game Recommender</a:t>
+            </a:r>
+            <a:endParaRPr lang="en-US" sz="900" dirty="0"/>
+          </a:p>
+        </p:txBody>
+      </p:sp>
+      <p:sp>
+        <p:nvSpPr>
+          <p:cNvPr id="24" name="Text 21"/>
+          <p:cNvSpPr/>
+          <p:nvPr/>
+        </p:nvSpPr>
+        <p:spPr>
+          <a:xfrm>
+            <a:off x="11064240" y="6400800"/>
+            <a:ext cx="457200" cy="274320"/>
+          </a:xfrm>
+          <a:prstGeom prst="rect">
+            <a:avLst/>
+          </a:prstGeom>
+          <a:noFill/>
+          <a:ln/>
+        </p:spPr>
+        <p:txBody>
+          <a:bodyPr wrap="square" lIns="0" tIns="0" rIns="0" bIns="0" rtlCol="0" anchor="ctr"/>
+          <a:lstStyle/>
+          <a:p>
+            <a:pPr algn="r" indent="0" marL="0">
+              <a:buNone/>
+            </a:pPr>
+            <a:r>
+              <a:rPr lang="en-US" sz="900" dirty="0">
+                <a:solidFill>
+                  <a:srgbClr val="9AA0B4"/>
+                </a:solidFill>
+                <a:latin typeface="Calibri" pitchFamily="34" charset="0"/>
+                <a:ea typeface="Calibri" pitchFamily="34" charset="-122"/>
+                <a:cs typeface="Calibri" pitchFamily="34" charset="-120"/>
+              </a:rPr>
+              <a:t>14</a:t>
+            </a:r>
+            <a:endParaRPr lang="en-US" sz="900" dirty="0"/>
+          </a:p>
+        </p:txBody>
+      </p:sp>
+    </p:spTree>
+  </p:cSld>
+  <p:clrMapOvr>
+    <a:masterClrMapping/>
+  </p:clrMapOvr>
+</p:sld>
+</file>
+
+<file path=ppt/slides/slide15.xml><?xml version="1.0" encoding="utf-8"?>
+<p:sld xmlns:a="http://schemas.openxmlformats.org/drawingml/2006/main" xmlns:r="http://schemas.openxmlformats.org/officeDocument/2006/relationships" xmlns:p="http://schemas.openxmlformats.org/presentationml/2006/main">
+  <p:cSld name="Slide 15">
+    <p:bg>
+      <p:bgPr>
+        <a:solidFill>
+          <a:srgbClr val="0F1117"/>
+        </a:solidFill>
+      </p:bgPr>
+    </p:bg>
+    <p:spTree>
+      <p:nvGrpSpPr>
+        <p:cNvPr id="1" name=""/>
+        <p:cNvGrpSpPr/>
+        <p:nvPr/>
+      </p:nvGrpSpPr>
+      <p:grpSpPr>
+        <a:xfrm>
+          <a:off x="0" y="0"/>
+          <a:ext cx="0" cy="0"/>
+          <a:chOff x="0" y="0"/>
+          <a:chExt cx="0" cy="0"/>
+        </a:xfrm>
+      </p:grpSpPr>
+      <p:sp>
+        <p:nvSpPr>
+          <p:cNvPr id="2" name="Shape 0"/>
+          <p:cNvSpPr/>
+          <p:nvPr/>
+        </p:nvSpPr>
+        <p:spPr>
+          <a:xfrm>
+            <a:off x="640080" y="566928"/>
+            <a:ext cx="146304" cy="146304"/>
+          </a:xfrm>
+          <a:prstGeom prst="ellipse">
             <a:avLst/>
           </a:prstGeom>
           <a:solidFill>
@@ -7145,14 +9062,14 @@
       </p:sp>
       <p:sp>
         <p:nvSpPr>
-          <p:cNvPr id="19" name="Text 17"/>
-          <p:cNvSpPr/>
-          <p:nvPr/>
-        </p:nvSpPr>
-        <p:spPr>
-          <a:xfrm>
-            <a:off x="9258300" y="2423160"/>
-            <a:ext cx="2080260" cy="365760"/>
+          <p:cNvPr id="3" name="Text 1"/>
+          <p:cNvSpPr/>
+          <p:nvPr/>
+        </p:nvSpPr>
+        <p:spPr>
+          <a:xfrm>
+            <a:off x="896112" y="457200"/>
+            <a:ext cx="9144000" cy="365760"/>
           </a:xfrm>
           <a:prstGeom prst="rect">
             <a:avLst/>
@@ -7168,30 +9085,30 @@
               <a:buNone/>
             </a:pPr>
             <a:r>
-              <a:rPr lang="en-US" sz="1100" b="1" spc="100" kern="0" dirty="0">
-                <a:solidFill>
-                  <a:srgbClr val="9AA0B4"/>
-                </a:solidFill>
-                <a:latin typeface="Calibri" pitchFamily="34" charset="0"/>
-                <a:ea typeface="Calibri" pitchFamily="34" charset="-122"/>
-                <a:cs typeface="Calibri" pitchFamily="34" charset="-120"/>
-              </a:rPr>
-              <a:t>PACKAGES</a:t>
-            </a:r>
-            <a:endParaRPr lang="en-US" sz="1100" dirty="0"/>
-          </a:p>
-        </p:txBody>
-      </p:sp>
-      <p:sp>
-        <p:nvSpPr>
-          <p:cNvPr id="20" name="Text 18"/>
-          <p:cNvSpPr/>
-          <p:nvPr/>
-        </p:nvSpPr>
-        <p:spPr>
-          <a:xfrm>
-            <a:off x="9258300" y="2834640"/>
-            <a:ext cx="2080260" cy="640080"/>
+              <a:rPr lang="en-US" sz="1200" b="1" spc="300" kern="0" dirty="0">
+                <a:solidFill>
+                  <a:srgbClr val="FFB347"/>
+                </a:solidFill>
+                <a:latin typeface="Calibri" pitchFamily="34" charset="0"/>
+                <a:ea typeface="Calibri" pitchFamily="34" charset="-122"/>
+                <a:cs typeface="Calibri" pitchFamily="34" charset="-120"/>
+              </a:rPr>
+              <a:t>UNDER THE HOOD</a:t>
+            </a:r>
+            <a:endParaRPr lang="en-US" sz="1200" dirty="0"/>
+          </a:p>
+        </p:txBody>
+      </p:sp>
+      <p:sp>
+        <p:nvSpPr>
+          <p:cNvPr id="4" name="Text 2"/>
+          <p:cNvSpPr/>
+          <p:nvPr/>
+        </p:nvSpPr>
+        <p:spPr>
+          <a:xfrm>
+            <a:off x="640080" y="777240"/>
+            <a:ext cx="10881360" cy="731520"/>
           </a:xfrm>
           <a:prstGeom prst="rect">
             <a:avLst/>
@@ -7207,29 +9124,29 @@
               <a:buNone/>
             </a:pPr>
             <a:r>
-              <a:rPr lang="en-US" sz="1500" b="1" dirty="0">
+              <a:rPr lang="en-US" sz="3200" b="1" dirty="0">
                 <a:solidFill>
                   <a:srgbClr val="ECECF3"/>
                 </a:solidFill>
-                <a:latin typeface="Calibri" pitchFamily="34" charset="0"/>
-                <a:ea typeface="Calibri" pitchFamily="34" charset="-122"/>
-                <a:cs typeface="Calibri" pitchFamily="34" charset="-120"/>
-              </a:rPr>
-              <a:t>pnpm</a:t>
-            </a:r>
-            <a:endParaRPr lang="en-US" sz="1500" dirty="0"/>
-          </a:p>
-        </p:txBody>
-      </p:sp>
-      <p:sp>
-        <p:nvSpPr>
-          <p:cNvPr id="21" name="Shape 19"/>
-          <p:cNvSpPr/>
-          <p:nvPr/>
-        </p:nvSpPr>
-        <p:spPr>
-          <a:xfrm>
-            <a:off x="640080" y="4023360"/>
+                <a:latin typeface="Georgia" pitchFamily="34" charset="0"/>
+                <a:ea typeface="Georgia" pitchFamily="34" charset="-122"/>
+                <a:cs typeface="Georgia" pitchFamily="34" charset="-120"/>
+              </a:rPr>
+              <a:t>Tech stack &amp; open data</a:t>
+            </a:r>
+            <a:endParaRPr lang="en-US" sz="3200" dirty="0"/>
+          </a:p>
+        </p:txBody>
+      </p:sp>
+      <p:sp>
+        <p:nvSpPr>
+          <p:cNvPr id="5" name="Shape 3"/>
+          <p:cNvSpPr/>
+          <p:nvPr/>
+        </p:nvSpPr>
+        <p:spPr>
+          <a:xfrm>
+            <a:off x="640080" y="2103120"/>
             <a:ext cx="2446020" cy="1554480"/>
           </a:xfrm>
           <a:prstGeom prst="roundRect">
@@ -7257,13 +9174,13 @@
       </p:sp>
       <p:sp>
         <p:nvSpPr>
-          <p:cNvPr id="22" name="Shape 20"/>
-          <p:cNvSpPr/>
-          <p:nvPr/>
-        </p:nvSpPr>
-        <p:spPr>
-          <a:xfrm>
-            <a:off x="640080" y="4023360"/>
+          <p:cNvPr id="6" name="Shape 4"/>
+          <p:cNvSpPr/>
+          <p:nvPr/>
+        </p:nvSpPr>
+        <p:spPr>
+          <a:xfrm>
+            <a:off x="640080" y="2103120"/>
             <a:ext cx="2446020" cy="82296"/>
           </a:xfrm>
           <a:prstGeom prst="rect">
@@ -7277,13 +9194,13 @@
       </p:sp>
       <p:sp>
         <p:nvSpPr>
-          <p:cNvPr id="23" name="Text 21"/>
-          <p:cNvSpPr/>
-          <p:nvPr/>
-        </p:nvSpPr>
-        <p:spPr>
-          <a:xfrm>
-            <a:off x="822960" y="4343400"/>
+          <p:cNvPr id="7" name="Text 5"/>
+          <p:cNvSpPr/>
+          <p:nvPr/>
+        </p:nvSpPr>
+        <p:spPr>
+          <a:xfrm>
+            <a:off x="822960" y="2423160"/>
             <a:ext cx="2080260" cy="365760"/>
           </a:xfrm>
           <a:prstGeom prst="rect">
@@ -7308,7 +9225,7 @@
                 <a:ea typeface="Calibri" pitchFamily="34" charset="-122"/>
                 <a:cs typeface="Calibri" pitchFamily="34" charset="-120"/>
               </a:rPr>
-              <a:t>AI</a:t>
+              <a:t>ENGINE</a:t>
             </a:r>
             <a:endParaRPr lang="en-US" sz="1100" dirty="0"/>
           </a:p>
@@ -7316,13 +9233,13 @@
       </p:sp>
       <p:sp>
         <p:nvSpPr>
-          <p:cNvPr id="24" name="Text 22"/>
-          <p:cNvSpPr/>
-          <p:nvPr/>
-        </p:nvSpPr>
-        <p:spPr>
-          <a:xfrm>
-            <a:off x="822960" y="4754880"/>
+          <p:cNvPr id="8" name="Text 6"/>
+          <p:cNvSpPr/>
+          <p:nvPr/>
+        </p:nvSpPr>
+        <p:spPr>
+          <a:xfrm>
+            <a:off x="822960" y="2834640"/>
             <a:ext cx="2080260" cy="640080"/>
           </a:xfrm>
           <a:prstGeom prst="rect">
@@ -7347,7 +9264,7 @@
                 <a:ea typeface="Calibri" pitchFamily="34" charset="-122"/>
                 <a:cs typeface="Calibri" pitchFamily="34" charset="-120"/>
               </a:rPr>
-              <a:t>OpenRouter (Qwen3)</a:t>
+              <a:t>C → cinematch.exe</a:t>
             </a:r>
             <a:endParaRPr lang="en-US" sz="1500" dirty="0"/>
           </a:p>
@@ -7355,13 +9272,13 @@
       </p:sp>
       <p:sp>
         <p:nvSpPr>
-          <p:cNvPr id="25" name="Shape 23"/>
-          <p:cNvSpPr/>
-          <p:nvPr/>
-        </p:nvSpPr>
-        <p:spPr>
-          <a:xfrm>
-            <a:off x="3451860" y="4023360"/>
+          <p:cNvPr id="9" name="Shape 7"/>
+          <p:cNvSpPr/>
+          <p:nvPr/>
+        </p:nvSpPr>
+        <p:spPr>
+          <a:xfrm>
+            <a:off x="3451860" y="2103120"/>
             <a:ext cx="2446020" cy="1554480"/>
           </a:xfrm>
           <a:prstGeom prst="roundRect">
@@ -7389,13 +9306,13 @@
       </p:sp>
       <p:sp>
         <p:nvSpPr>
-          <p:cNvPr id="26" name="Shape 24"/>
-          <p:cNvSpPr/>
-          <p:nvPr/>
-        </p:nvSpPr>
-        <p:spPr>
-          <a:xfrm>
-            <a:off x="3451860" y="4023360"/>
+          <p:cNvPr id="10" name="Shape 8"/>
+          <p:cNvSpPr/>
+          <p:nvPr/>
+        </p:nvSpPr>
+        <p:spPr>
+          <a:xfrm>
+            <a:off x="3451860" y="2103120"/>
             <a:ext cx="2446020" cy="82296"/>
           </a:xfrm>
           <a:prstGeom prst="rect">
@@ -7409,13 +9326,13 @@
       </p:sp>
       <p:sp>
         <p:nvSpPr>
-          <p:cNvPr id="27" name="Text 25"/>
-          <p:cNvSpPr/>
-          <p:nvPr/>
-        </p:nvSpPr>
-        <p:spPr>
-          <a:xfrm>
-            <a:off x="3634740" y="4343400"/>
+          <p:cNvPr id="11" name="Text 9"/>
+          <p:cNvSpPr/>
+          <p:nvPr/>
+        </p:nvSpPr>
+        <p:spPr>
+          <a:xfrm>
+            <a:off x="3634740" y="2423160"/>
             <a:ext cx="2080260" cy="365760"/>
           </a:xfrm>
           <a:prstGeom prst="rect">
@@ -7440,7 +9357,7 @@
                 <a:ea typeface="Calibri" pitchFamily="34" charset="-122"/>
                 <a:cs typeface="Calibri" pitchFamily="34" charset="-120"/>
               </a:rPr>
-              <a:t>MOVIES</a:t>
+              <a:t>BACKEND</a:t>
             </a:r>
             <a:endParaRPr lang="en-US" sz="1100" dirty="0"/>
           </a:p>
@@ -7448,13 +9365,13 @@
       </p:sp>
       <p:sp>
         <p:nvSpPr>
-          <p:cNvPr id="28" name="Text 26"/>
-          <p:cNvSpPr/>
-          <p:nvPr/>
-        </p:nvSpPr>
-        <p:spPr>
-          <a:xfrm>
-            <a:off x="3634740" y="4754880"/>
+          <p:cNvPr id="12" name="Text 10"/>
+          <p:cNvSpPr/>
+          <p:nvPr/>
+        </p:nvSpPr>
+        <p:spPr>
+          <a:xfrm>
+            <a:off x="3634740" y="2834640"/>
             <a:ext cx="2080260" cy="640080"/>
           </a:xfrm>
           <a:prstGeom prst="rect">
@@ -7479,7 +9396,7 @@
                 <a:ea typeface="Calibri" pitchFamily="34" charset="-122"/>
                 <a:cs typeface="Calibri" pitchFamily="34" charset="-120"/>
               </a:rPr>
-              <a:t>TMDB open dataset</a:t>
+              <a:t>Node.js + Express</a:t>
             </a:r>
             <a:endParaRPr lang="en-US" sz="1500" dirty="0"/>
           </a:p>
@@ -7487,13 +9404,13 @@
       </p:sp>
       <p:sp>
         <p:nvSpPr>
-          <p:cNvPr id="29" name="Shape 27"/>
-          <p:cNvSpPr/>
-          <p:nvPr/>
-        </p:nvSpPr>
-        <p:spPr>
-          <a:xfrm>
-            <a:off x="6263640" y="4023360"/>
+          <p:cNvPr id="13" name="Shape 11"/>
+          <p:cNvSpPr/>
+          <p:nvPr/>
+        </p:nvSpPr>
+        <p:spPr>
+          <a:xfrm>
+            <a:off x="6263640" y="2103120"/>
             <a:ext cx="2446020" cy="1554480"/>
           </a:xfrm>
           <a:prstGeom prst="roundRect">
@@ -7521,13 +9438,13 @@
       </p:sp>
       <p:sp>
         <p:nvSpPr>
-          <p:cNvPr id="30" name="Shape 28"/>
-          <p:cNvSpPr/>
-          <p:nvPr/>
-        </p:nvSpPr>
-        <p:spPr>
-          <a:xfrm>
-            <a:off x="6263640" y="4023360"/>
+          <p:cNvPr id="14" name="Shape 12"/>
+          <p:cNvSpPr/>
+          <p:nvPr/>
+        </p:nvSpPr>
+        <p:spPr>
+          <a:xfrm>
+            <a:off x="6263640" y="2103120"/>
             <a:ext cx="2446020" cy="82296"/>
           </a:xfrm>
           <a:prstGeom prst="rect">
@@ -7541,13 +9458,13 @@
       </p:sp>
       <p:sp>
         <p:nvSpPr>
-          <p:cNvPr id="31" name="Text 29"/>
-          <p:cNvSpPr/>
-          <p:nvPr/>
-        </p:nvSpPr>
-        <p:spPr>
-          <a:xfrm>
-            <a:off x="6446520" y="4343400"/>
+          <p:cNvPr id="15" name="Text 13"/>
+          <p:cNvSpPr/>
+          <p:nvPr/>
+        </p:nvSpPr>
+        <p:spPr>
+          <a:xfrm>
+            <a:off x="6446520" y="2423160"/>
             <a:ext cx="2080260" cy="365760"/>
           </a:xfrm>
           <a:prstGeom prst="rect">
@@ -7572,7 +9489,7 @@
                 <a:ea typeface="Calibri" pitchFamily="34" charset="-122"/>
                 <a:cs typeface="Calibri" pitchFamily="34" charset="-120"/>
               </a:rPr>
-              <a:t>GAMES</a:t>
+              <a:t>FRONTEND</a:t>
             </a:r>
             <a:endParaRPr lang="en-US" sz="1100" dirty="0"/>
           </a:p>
@@ -7580,13 +9497,13 @@
       </p:sp>
       <p:sp>
         <p:nvSpPr>
-          <p:cNvPr id="32" name="Text 30"/>
-          <p:cNvSpPr/>
-          <p:nvPr/>
-        </p:nvSpPr>
-        <p:spPr>
-          <a:xfrm>
-            <a:off x="6446520" y="4754880"/>
+          <p:cNvPr id="16" name="Text 14"/>
+          <p:cNvSpPr/>
+          <p:nvPr/>
+        </p:nvSpPr>
+        <p:spPr>
+          <a:xfrm>
+            <a:off x="6446520" y="2834640"/>
             <a:ext cx="2080260" cy="640080"/>
           </a:xfrm>
           <a:prstGeom prst="rect">
@@ -7611,7 +9528,7 @@
                 <a:ea typeface="Calibri" pitchFamily="34" charset="-122"/>
                 <a:cs typeface="Calibri" pitchFamily="34" charset="-120"/>
               </a:rPr>
-              <a:t>RAWG open dataset</a:t>
+              <a:t>Vite + React</a:t>
             </a:r>
             <a:endParaRPr lang="en-US" sz="1500" dirty="0"/>
           </a:p>
@@ -7619,13 +9536,13 @@
       </p:sp>
       <p:sp>
         <p:nvSpPr>
-          <p:cNvPr id="33" name="Shape 31"/>
-          <p:cNvSpPr/>
-          <p:nvPr/>
-        </p:nvSpPr>
-        <p:spPr>
-          <a:xfrm>
-            <a:off x="9075420" y="4023360"/>
+          <p:cNvPr id="17" name="Shape 15"/>
+          <p:cNvSpPr/>
+          <p:nvPr/>
+        </p:nvSpPr>
+        <p:spPr>
+          <a:xfrm>
+            <a:off x="9075420" y="2103120"/>
             <a:ext cx="2446020" cy="1554480"/>
           </a:xfrm>
           <a:prstGeom prst="roundRect">
@@ -7653,13 +9570,13 @@
       </p:sp>
       <p:sp>
         <p:nvSpPr>
-          <p:cNvPr id="34" name="Shape 32"/>
-          <p:cNvSpPr/>
-          <p:nvPr/>
-        </p:nvSpPr>
-        <p:spPr>
-          <a:xfrm>
-            <a:off x="9075420" y="4023360"/>
+          <p:cNvPr id="18" name="Shape 16"/>
+          <p:cNvSpPr/>
+          <p:nvPr/>
+        </p:nvSpPr>
+        <p:spPr>
+          <a:xfrm>
+            <a:off x="9075420" y="2103120"/>
             <a:ext cx="2446020" cy="82296"/>
           </a:xfrm>
           <a:prstGeom prst="rect">
@@ -7673,6 +9590,534 @@
       </p:sp>
       <p:sp>
         <p:nvSpPr>
+          <p:cNvPr id="19" name="Text 17"/>
+          <p:cNvSpPr/>
+          <p:nvPr/>
+        </p:nvSpPr>
+        <p:spPr>
+          <a:xfrm>
+            <a:off x="9258300" y="2423160"/>
+            <a:ext cx="2080260" cy="365760"/>
+          </a:xfrm>
+          <a:prstGeom prst="rect">
+            <a:avLst/>
+          </a:prstGeom>
+          <a:noFill/>
+          <a:ln/>
+        </p:spPr>
+        <p:txBody>
+          <a:bodyPr wrap="square" lIns="0" tIns="0" rIns="0" bIns="0" rtlCol="0" anchor="ctr"/>
+          <a:lstStyle/>
+          <a:p>
+            <a:pPr indent="0" marL="0">
+              <a:buNone/>
+            </a:pPr>
+            <a:r>
+              <a:rPr lang="en-US" sz="1100" b="1" spc="100" kern="0" dirty="0">
+                <a:solidFill>
+                  <a:srgbClr val="9AA0B4"/>
+                </a:solidFill>
+                <a:latin typeface="Calibri" pitchFamily="34" charset="0"/>
+                <a:ea typeface="Calibri" pitchFamily="34" charset="-122"/>
+                <a:cs typeface="Calibri" pitchFamily="34" charset="-120"/>
+              </a:rPr>
+              <a:t>PACKAGES</a:t>
+            </a:r>
+            <a:endParaRPr lang="en-US" sz="1100" dirty="0"/>
+          </a:p>
+        </p:txBody>
+      </p:sp>
+      <p:sp>
+        <p:nvSpPr>
+          <p:cNvPr id="20" name="Text 18"/>
+          <p:cNvSpPr/>
+          <p:nvPr/>
+        </p:nvSpPr>
+        <p:spPr>
+          <a:xfrm>
+            <a:off x="9258300" y="2834640"/>
+            <a:ext cx="2080260" cy="640080"/>
+          </a:xfrm>
+          <a:prstGeom prst="rect">
+            <a:avLst/>
+          </a:prstGeom>
+          <a:noFill/>
+          <a:ln/>
+        </p:spPr>
+        <p:txBody>
+          <a:bodyPr wrap="square" lIns="0" tIns="0" rIns="0" bIns="0" rtlCol="0" anchor="ctr"/>
+          <a:lstStyle/>
+          <a:p>
+            <a:pPr indent="0" marL="0">
+              <a:buNone/>
+            </a:pPr>
+            <a:r>
+              <a:rPr lang="en-US" sz="1500" b="1" dirty="0">
+                <a:solidFill>
+                  <a:srgbClr val="ECECF3"/>
+                </a:solidFill>
+                <a:latin typeface="Calibri" pitchFamily="34" charset="0"/>
+                <a:ea typeface="Calibri" pitchFamily="34" charset="-122"/>
+                <a:cs typeface="Calibri" pitchFamily="34" charset="-120"/>
+              </a:rPr>
+              <a:t>pnpm</a:t>
+            </a:r>
+            <a:endParaRPr lang="en-US" sz="1500" dirty="0"/>
+          </a:p>
+        </p:txBody>
+      </p:sp>
+      <p:sp>
+        <p:nvSpPr>
+          <p:cNvPr id="21" name="Shape 19"/>
+          <p:cNvSpPr/>
+          <p:nvPr/>
+        </p:nvSpPr>
+        <p:spPr>
+          <a:xfrm>
+            <a:off x="640080" y="4023360"/>
+            <a:ext cx="2446020" cy="1554480"/>
+          </a:xfrm>
+          <a:prstGeom prst="roundRect">
+            <a:avLst>
+              <a:gd name="adj" fmla="val 4706"/>
+            </a:avLst>
+          </a:prstGeom>
+          <a:solidFill>
+            <a:srgbClr val="11141D"/>
+          </a:solidFill>
+          <a:ln w="12700">
+            <a:solidFill>
+              <a:srgbClr val="2A2F3E"/>
+            </a:solidFill>
+            <a:prstDash val="solid"/>
+          </a:ln>
+          <a:effectLst>
+            <a:outerShdw sx="100000" sy="100000" kx="0" ky="0" algn="bl" rotWithShape="0" blurRad="101600" dist="38100" dir="8100000">
+              <a:srgbClr val="000000">
+                <a:alpha val="35000"/>
+              </a:srgbClr>
+            </a:outerShdw>
+          </a:effectLst>
+        </p:spPr>
+      </p:sp>
+      <p:sp>
+        <p:nvSpPr>
+          <p:cNvPr id="22" name="Shape 20"/>
+          <p:cNvSpPr/>
+          <p:nvPr/>
+        </p:nvSpPr>
+        <p:spPr>
+          <a:xfrm>
+            <a:off x="640080" y="4023360"/>
+            <a:ext cx="2446020" cy="82296"/>
+          </a:xfrm>
+          <a:prstGeom prst="rect">
+            <a:avLst/>
+          </a:prstGeom>
+          <a:solidFill>
+            <a:srgbClr val="FFB347"/>
+          </a:solidFill>
+          <a:ln/>
+        </p:spPr>
+      </p:sp>
+      <p:sp>
+        <p:nvSpPr>
+          <p:cNvPr id="23" name="Text 21"/>
+          <p:cNvSpPr/>
+          <p:nvPr/>
+        </p:nvSpPr>
+        <p:spPr>
+          <a:xfrm>
+            <a:off x="822960" y="4343400"/>
+            <a:ext cx="2080260" cy="365760"/>
+          </a:xfrm>
+          <a:prstGeom prst="rect">
+            <a:avLst/>
+          </a:prstGeom>
+          <a:noFill/>
+          <a:ln/>
+        </p:spPr>
+        <p:txBody>
+          <a:bodyPr wrap="square" lIns="0" tIns="0" rIns="0" bIns="0" rtlCol="0" anchor="ctr"/>
+          <a:lstStyle/>
+          <a:p>
+            <a:pPr indent="0" marL="0">
+              <a:buNone/>
+            </a:pPr>
+            <a:r>
+              <a:rPr lang="en-US" sz="1100" b="1" spc="100" kern="0" dirty="0">
+                <a:solidFill>
+                  <a:srgbClr val="9AA0B4"/>
+                </a:solidFill>
+                <a:latin typeface="Calibri" pitchFamily="34" charset="0"/>
+                <a:ea typeface="Calibri" pitchFamily="34" charset="-122"/>
+                <a:cs typeface="Calibri" pitchFamily="34" charset="-120"/>
+              </a:rPr>
+              <a:t>AI</a:t>
+            </a:r>
+            <a:endParaRPr lang="en-US" sz="1100" dirty="0"/>
+          </a:p>
+        </p:txBody>
+      </p:sp>
+      <p:sp>
+        <p:nvSpPr>
+          <p:cNvPr id="24" name="Text 22"/>
+          <p:cNvSpPr/>
+          <p:nvPr/>
+        </p:nvSpPr>
+        <p:spPr>
+          <a:xfrm>
+            <a:off x="822960" y="4754880"/>
+            <a:ext cx="2080260" cy="640080"/>
+          </a:xfrm>
+          <a:prstGeom prst="rect">
+            <a:avLst/>
+          </a:prstGeom>
+          <a:noFill/>
+          <a:ln/>
+        </p:spPr>
+        <p:txBody>
+          <a:bodyPr wrap="square" lIns="0" tIns="0" rIns="0" bIns="0" rtlCol="0" anchor="ctr"/>
+          <a:lstStyle/>
+          <a:p>
+            <a:pPr indent="0" marL="0">
+              <a:buNone/>
+            </a:pPr>
+            <a:r>
+              <a:rPr lang="en-US" sz="1500" b="1" dirty="0">
+                <a:solidFill>
+                  <a:srgbClr val="ECECF3"/>
+                </a:solidFill>
+                <a:latin typeface="Calibri" pitchFamily="34" charset="0"/>
+                <a:ea typeface="Calibri" pitchFamily="34" charset="-122"/>
+                <a:cs typeface="Calibri" pitchFamily="34" charset="-120"/>
+              </a:rPr>
+              <a:t>OpenRouter (Qwen3)</a:t>
+            </a:r>
+            <a:endParaRPr lang="en-US" sz="1500" dirty="0"/>
+          </a:p>
+        </p:txBody>
+      </p:sp>
+      <p:sp>
+        <p:nvSpPr>
+          <p:cNvPr id="25" name="Shape 23"/>
+          <p:cNvSpPr/>
+          <p:nvPr/>
+        </p:nvSpPr>
+        <p:spPr>
+          <a:xfrm>
+            <a:off x="3451860" y="4023360"/>
+            <a:ext cx="2446020" cy="1554480"/>
+          </a:xfrm>
+          <a:prstGeom prst="roundRect">
+            <a:avLst>
+              <a:gd name="adj" fmla="val 4706"/>
+            </a:avLst>
+          </a:prstGeom>
+          <a:solidFill>
+            <a:srgbClr val="11141D"/>
+          </a:solidFill>
+          <a:ln w="12700">
+            <a:solidFill>
+              <a:srgbClr val="2A2F3E"/>
+            </a:solidFill>
+            <a:prstDash val="solid"/>
+          </a:ln>
+          <a:effectLst>
+            <a:outerShdw sx="100000" sy="100000" kx="0" ky="0" algn="bl" rotWithShape="0" blurRad="101600" dist="38100" dir="8100000">
+              <a:srgbClr val="000000">
+                <a:alpha val="35000"/>
+              </a:srgbClr>
+            </a:outerShdw>
+          </a:effectLst>
+        </p:spPr>
+      </p:sp>
+      <p:sp>
+        <p:nvSpPr>
+          <p:cNvPr id="26" name="Shape 24"/>
+          <p:cNvSpPr/>
+          <p:nvPr/>
+        </p:nvSpPr>
+        <p:spPr>
+          <a:xfrm>
+            <a:off x="3451860" y="4023360"/>
+            <a:ext cx="2446020" cy="82296"/>
+          </a:xfrm>
+          <a:prstGeom prst="rect">
+            <a:avLst/>
+          </a:prstGeom>
+          <a:solidFill>
+            <a:srgbClr val="FFB347"/>
+          </a:solidFill>
+          <a:ln/>
+        </p:spPr>
+      </p:sp>
+      <p:sp>
+        <p:nvSpPr>
+          <p:cNvPr id="27" name="Text 25"/>
+          <p:cNvSpPr/>
+          <p:nvPr/>
+        </p:nvSpPr>
+        <p:spPr>
+          <a:xfrm>
+            <a:off x="3634740" y="4343400"/>
+            <a:ext cx="2080260" cy="365760"/>
+          </a:xfrm>
+          <a:prstGeom prst="rect">
+            <a:avLst/>
+          </a:prstGeom>
+          <a:noFill/>
+          <a:ln/>
+        </p:spPr>
+        <p:txBody>
+          <a:bodyPr wrap="square" lIns="0" tIns="0" rIns="0" bIns="0" rtlCol="0" anchor="ctr"/>
+          <a:lstStyle/>
+          <a:p>
+            <a:pPr indent="0" marL="0">
+              <a:buNone/>
+            </a:pPr>
+            <a:r>
+              <a:rPr lang="en-US" sz="1100" b="1" spc="100" kern="0" dirty="0">
+                <a:solidFill>
+                  <a:srgbClr val="9AA0B4"/>
+                </a:solidFill>
+                <a:latin typeface="Calibri" pitchFamily="34" charset="0"/>
+                <a:ea typeface="Calibri" pitchFamily="34" charset="-122"/>
+                <a:cs typeface="Calibri" pitchFamily="34" charset="-120"/>
+              </a:rPr>
+              <a:t>MOVIES</a:t>
+            </a:r>
+            <a:endParaRPr lang="en-US" sz="1100" dirty="0"/>
+          </a:p>
+        </p:txBody>
+      </p:sp>
+      <p:sp>
+        <p:nvSpPr>
+          <p:cNvPr id="28" name="Text 26"/>
+          <p:cNvSpPr/>
+          <p:nvPr/>
+        </p:nvSpPr>
+        <p:spPr>
+          <a:xfrm>
+            <a:off x="3634740" y="4754880"/>
+            <a:ext cx="2080260" cy="640080"/>
+          </a:xfrm>
+          <a:prstGeom prst="rect">
+            <a:avLst/>
+          </a:prstGeom>
+          <a:noFill/>
+          <a:ln/>
+        </p:spPr>
+        <p:txBody>
+          <a:bodyPr wrap="square" lIns="0" tIns="0" rIns="0" bIns="0" rtlCol="0" anchor="ctr"/>
+          <a:lstStyle/>
+          <a:p>
+            <a:pPr indent="0" marL="0">
+              <a:buNone/>
+            </a:pPr>
+            <a:r>
+              <a:rPr lang="en-US" sz="1500" b="1" dirty="0">
+                <a:solidFill>
+                  <a:srgbClr val="ECECF3"/>
+                </a:solidFill>
+                <a:latin typeface="Calibri" pitchFamily="34" charset="0"/>
+                <a:ea typeface="Calibri" pitchFamily="34" charset="-122"/>
+                <a:cs typeface="Calibri" pitchFamily="34" charset="-120"/>
+              </a:rPr>
+              <a:t>TMDB open dataset</a:t>
+            </a:r>
+            <a:endParaRPr lang="en-US" sz="1500" dirty="0"/>
+          </a:p>
+        </p:txBody>
+      </p:sp>
+      <p:sp>
+        <p:nvSpPr>
+          <p:cNvPr id="29" name="Shape 27"/>
+          <p:cNvSpPr/>
+          <p:nvPr/>
+        </p:nvSpPr>
+        <p:spPr>
+          <a:xfrm>
+            <a:off x="6263640" y="4023360"/>
+            <a:ext cx="2446020" cy="1554480"/>
+          </a:xfrm>
+          <a:prstGeom prst="roundRect">
+            <a:avLst>
+              <a:gd name="adj" fmla="val 4706"/>
+            </a:avLst>
+          </a:prstGeom>
+          <a:solidFill>
+            <a:srgbClr val="11141D"/>
+          </a:solidFill>
+          <a:ln w="12700">
+            <a:solidFill>
+              <a:srgbClr val="2A2F3E"/>
+            </a:solidFill>
+            <a:prstDash val="solid"/>
+          </a:ln>
+          <a:effectLst>
+            <a:outerShdw sx="100000" sy="100000" kx="0" ky="0" algn="bl" rotWithShape="0" blurRad="101600" dist="38100" dir="8100000">
+              <a:srgbClr val="000000">
+                <a:alpha val="35000"/>
+              </a:srgbClr>
+            </a:outerShdw>
+          </a:effectLst>
+        </p:spPr>
+      </p:sp>
+      <p:sp>
+        <p:nvSpPr>
+          <p:cNvPr id="30" name="Shape 28"/>
+          <p:cNvSpPr/>
+          <p:nvPr/>
+        </p:nvSpPr>
+        <p:spPr>
+          <a:xfrm>
+            <a:off x="6263640" y="4023360"/>
+            <a:ext cx="2446020" cy="82296"/>
+          </a:xfrm>
+          <a:prstGeom prst="rect">
+            <a:avLst/>
+          </a:prstGeom>
+          <a:solidFill>
+            <a:srgbClr val="FFB347"/>
+          </a:solidFill>
+          <a:ln/>
+        </p:spPr>
+      </p:sp>
+      <p:sp>
+        <p:nvSpPr>
+          <p:cNvPr id="31" name="Text 29"/>
+          <p:cNvSpPr/>
+          <p:nvPr/>
+        </p:nvSpPr>
+        <p:spPr>
+          <a:xfrm>
+            <a:off x="6446520" y="4343400"/>
+            <a:ext cx="2080260" cy="365760"/>
+          </a:xfrm>
+          <a:prstGeom prst="rect">
+            <a:avLst/>
+          </a:prstGeom>
+          <a:noFill/>
+          <a:ln/>
+        </p:spPr>
+        <p:txBody>
+          <a:bodyPr wrap="square" lIns="0" tIns="0" rIns="0" bIns="0" rtlCol="0" anchor="ctr"/>
+          <a:lstStyle/>
+          <a:p>
+            <a:pPr indent="0" marL="0">
+              <a:buNone/>
+            </a:pPr>
+            <a:r>
+              <a:rPr lang="en-US" sz="1100" b="1" spc="100" kern="0" dirty="0">
+                <a:solidFill>
+                  <a:srgbClr val="9AA0B4"/>
+                </a:solidFill>
+                <a:latin typeface="Calibri" pitchFamily="34" charset="0"/>
+                <a:ea typeface="Calibri" pitchFamily="34" charset="-122"/>
+                <a:cs typeface="Calibri" pitchFamily="34" charset="-120"/>
+              </a:rPr>
+              <a:t>GAMES</a:t>
+            </a:r>
+            <a:endParaRPr lang="en-US" sz="1100" dirty="0"/>
+          </a:p>
+        </p:txBody>
+      </p:sp>
+      <p:sp>
+        <p:nvSpPr>
+          <p:cNvPr id="32" name="Text 30"/>
+          <p:cNvSpPr/>
+          <p:nvPr/>
+        </p:nvSpPr>
+        <p:spPr>
+          <a:xfrm>
+            <a:off x="6446520" y="4754880"/>
+            <a:ext cx="2080260" cy="640080"/>
+          </a:xfrm>
+          <a:prstGeom prst="rect">
+            <a:avLst/>
+          </a:prstGeom>
+          <a:noFill/>
+          <a:ln/>
+        </p:spPr>
+        <p:txBody>
+          <a:bodyPr wrap="square" lIns="0" tIns="0" rIns="0" bIns="0" rtlCol="0" anchor="ctr"/>
+          <a:lstStyle/>
+          <a:p>
+            <a:pPr indent="0" marL="0">
+              <a:buNone/>
+            </a:pPr>
+            <a:r>
+              <a:rPr lang="en-US" sz="1500" b="1" dirty="0">
+                <a:solidFill>
+                  <a:srgbClr val="ECECF3"/>
+                </a:solidFill>
+                <a:latin typeface="Calibri" pitchFamily="34" charset="0"/>
+                <a:ea typeface="Calibri" pitchFamily="34" charset="-122"/>
+                <a:cs typeface="Calibri" pitchFamily="34" charset="-120"/>
+              </a:rPr>
+              <a:t>RAWG open dataset</a:t>
+            </a:r>
+            <a:endParaRPr lang="en-US" sz="1500" dirty="0"/>
+          </a:p>
+        </p:txBody>
+      </p:sp>
+      <p:sp>
+        <p:nvSpPr>
+          <p:cNvPr id="33" name="Shape 31"/>
+          <p:cNvSpPr/>
+          <p:nvPr/>
+        </p:nvSpPr>
+        <p:spPr>
+          <a:xfrm>
+            <a:off x="9075420" y="4023360"/>
+            <a:ext cx="2446020" cy="1554480"/>
+          </a:xfrm>
+          <a:prstGeom prst="roundRect">
+            <a:avLst>
+              <a:gd name="adj" fmla="val 4706"/>
+            </a:avLst>
+          </a:prstGeom>
+          <a:solidFill>
+            <a:srgbClr val="11141D"/>
+          </a:solidFill>
+          <a:ln w="12700">
+            <a:solidFill>
+              <a:srgbClr val="2A2F3E"/>
+            </a:solidFill>
+            <a:prstDash val="solid"/>
+          </a:ln>
+          <a:effectLst>
+            <a:outerShdw sx="100000" sy="100000" kx="0" ky="0" algn="bl" rotWithShape="0" blurRad="101600" dist="38100" dir="8100000">
+              <a:srgbClr val="000000">
+                <a:alpha val="35000"/>
+              </a:srgbClr>
+            </a:outerShdw>
+          </a:effectLst>
+        </p:spPr>
+      </p:sp>
+      <p:sp>
+        <p:nvSpPr>
+          <p:cNvPr id="34" name="Shape 32"/>
+          <p:cNvSpPr/>
+          <p:nvPr/>
+        </p:nvSpPr>
+        <p:spPr>
+          <a:xfrm>
+            <a:off x="9075420" y="4023360"/>
+            <a:ext cx="2446020" cy="82296"/>
+          </a:xfrm>
+          <a:prstGeom prst="rect">
+            <a:avLst/>
+          </a:prstGeom>
+          <a:solidFill>
+            <a:srgbClr val="FFB347"/>
+          </a:solidFill>
+          <a:ln/>
+        </p:spPr>
+      </p:sp>
+      <p:sp>
+        <p:nvSpPr>
           <p:cNvPr id="35" name="Text 33"/>
           <p:cNvSpPr/>
           <p:nvPr/>
@@ -7835,7 +10280,7 @@
                 <a:ea typeface="Calibri" pitchFamily="34" charset="-122"/>
                 <a:cs typeface="Calibri" pitchFamily="34" charset="-120"/>
               </a:rPr>
-              <a:t>14</a:t>
+              <a:t>15</a:t>
             </a:r>
             <a:endParaRPr lang="en-US" sz="900" dirty="0"/>
           </a:p>
@@ -7849,9 +10294,672 @@
 </p:sld>
 </file>
 
-<file path=ppt/slides/slide15.xml><?xml version="1.0" encoding="utf-8"?>
+<file path=ppt/slides/slide16.xml><?xml version="1.0" encoding="utf-8"?>
 <p:sld xmlns:a="http://schemas.openxmlformats.org/drawingml/2006/main" xmlns:r="http://schemas.openxmlformats.org/officeDocument/2006/relationships" xmlns:p="http://schemas.openxmlformats.org/presentationml/2006/main">
-  <p:cSld name="Slide 15">
+  <p:cSld name="Slide 16">
+    <p:bg>
+      <p:bgPr>
+        <a:solidFill>
+          <a:srgbClr val="0F1117"/>
+        </a:solidFill>
+      </p:bgPr>
+    </p:bg>
+    <p:spTree>
+      <p:nvGrpSpPr>
+        <p:cNvPr id="1" name=""/>
+        <p:cNvGrpSpPr/>
+        <p:nvPr/>
+      </p:nvGrpSpPr>
+      <p:grpSpPr>
+        <a:xfrm>
+          <a:off x="0" y="0"/>
+          <a:ext cx="0" cy="0"/>
+          <a:chOff x="0" y="0"/>
+          <a:chExt cx="0" cy="0"/>
+        </a:xfrm>
+      </p:grpSpPr>
+      <p:sp>
+        <p:nvSpPr>
+          <p:cNvPr id="2" name="Shape 0"/>
+          <p:cNvSpPr/>
+          <p:nvPr/>
+        </p:nvSpPr>
+        <p:spPr>
+          <a:xfrm>
+            <a:off x="640080" y="566928"/>
+            <a:ext cx="146304" cy="146304"/>
+          </a:xfrm>
+          <a:prstGeom prst="ellipse">
+            <a:avLst/>
+          </a:prstGeom>
+          <a:solidFill>
+            <a:srgbClr val="FFB347"/>
+          </a:solidFill>
+          <a:ln/>
+        </p:spPr>
+      </p:sp>
+      <p:sp>
+        <p:nvSpPr>
+          <p:cNvPr id="3" name="Text 1"/>
+          <p:cNvSpPr/>
+          <p:nvPr/>
+        </p:nvSpPr>
+        <p:spPr>
+          <a:xfrm>
+            <a:off x="896112" y="457200"/>
+            <a:ext cx="9144000" cy="365760"/>
+          </a:xfrm>
+          <a:prstGeom prst="rect">
+            <a:avLst/>
+          </a:prstGeom>
+          <a:noFill/>
+          <a:ln/>
+        </p:spPr>
+        <p:txBody>
+          <a:bodyPr wrap="square" lIns="0" tIns="0" rIns="0" bIns="0" rtlCol="0" anchor="ctr"/>
+          <a:lstStyle/>
+          <a:p>
+            <a:pPr indent="0" marL="0">
+              <a:buNone/>
+            </a:pPr>
+            <a:r>
+              <a:rPr lang="en-US" sz="1200" b="1" spc="300" kern="0" dirty="0">
+                <a:solidFill>
+                  <a:srgbClr val="FFB347"/>
+                </a:solidFill>
+                <a:latin typeface="Calibri" pitchFamily="34" charset="0"/>
+                <a:ea typeface="Calibri" pitchFamily="34" charset="-122"/>
+                <a:cs typeface="Calibri" pitchFamily="34" charset="-120"/>
+              </a:rPr>
+              <a:t>LOOKING AHEAD</a:t>
+            </a:r>
+            <a:endParaRPr lang="en-US" sz="1200" dirty="0"/>
+          </a:p>
+        </p:txBody>
+      </p:sp>
+      <p:sp>
+        <p:nvSpPr>
+          <p:cNvPr id="4" name="Text 2"/>
+          <p:cNvSpPr/>
+          <p:nvPr/>
+        </p:nvSpPr>
+        <p:spPr>
+          <a:xfrm>
+            <a:off x="640080" y="777240"/>
+            <a:ext cx="10881360" cy="731520"/>
+          </a:xfrm>
+          <a:prstGeom prst="rect">
+            <a:avLst/>
+          </a:prstGeom>
+          <a:noFill/>
+          <a:ln/>
+        </p:spPr>
+        <p:txBody>
+          <a:bodyPr wrap="square" lIns="0" tIns="0" rIns="0" bIns="0" rtlCol="0" anchor="ctr"/>
+          <a:lstStyle/>
+          <a:p>
+            <a:pPr indent="0" marL="0">
+              <a:buNone/>
+            </a:pPr>
+            <a:r>
+              <a:rPr lang="en-US" sz="3200" b="1" dirty="0">
+                <a:solidFill>
+                  <a:srgbClr val="ECECF3"/>
+                </a:solidFill>
+                <a:latin typeface="Georgia" pitchFamily="34" charset="0"/>
+                <a:ea typeface="Georgia" pitchFamily="34" charset="-122"/>
+                <a:cs typeface="Georgia" pitchFamily="34" charset="-120"/>
+              </a:rPr>
+              <a:t>Limitations &amp; future work</a:t>
+            </a:r>
+            <a:endParaRPr lang="en-US" sz="3200" dirty="0"/>
+          </a:p>
+        </p:txBody>
+      </p:sp>
+      <p:sp>
+        <p:nvSpPr>
+          <p:cNvPr id="5" name="Shape 3"/>
+          <p:cNvSpPr/>
+          <p:nvPr/>
+        </p:nvSpPr>
+        <p:spPr>
+          <a:xfrm>
+            <a:off x="640080" y="1828800"/>
+            <a:ext cx="5212080" cy="4114800"/>
+          </a:xfrm>
+          <a:prstGeom prst="roundRect">
+            <a:avLst>
+              <a:gd name="adj" fmla="val 1778"/>
+            </a:avLst>
+          </a:prstGeom>
+          <a:solidFill>
+            <a:srgbClr val="11141D"/>
+          </a:solidFill>
+          <a:ln w="12700">
+            <a:solidFill>
+              <a:srgbClr val="2A2F3E"/>
+            </a:solidFill>
+            <a:prstDash val="solid"/>
+          </a:ln>
+          <a:effectLst>
+            <a:outerShdw sx="100000" sy="100000" kx="0" ky="0" algn="bl" rotWithShape="0" blurRad="101600" dist="38100" dir="8100000">
+              <a:srgbClr val="000000">
+                <a:alpha val="35000"/>
+              </a:srgbClr>
+            </a:outerShdw>
+          </a:effectLst>
+        </p:spPr>
+      </p:sp>
+      <p:sp>
+        <p:nvSpPr>
+          <p:cNvPr id="6" name="Text 4"/>
+          <p:cNvSpPr/>
+          <p:nvPr/>
+        </p:nvSpPr>
+        <p:spPr>
+          <a:xfrm>
+            <a:off x="960120" y="2057400"/>
+            <a:ext cx="4572000" cy="365760"/>
+          </a:xfrm>
+          <a:prstGeom prst="rect">
+            <a:avLst/>
+          </a:prstGeom>
+          <a:noFill/>
+          <a:ln/>
+        </p:spPr>
+        <p:txBody>
+          <a:bodyPr wrap="square" lIns="0" tIns="0" rIns="0" bIns="0" rtlCol="0" anchor="ctr"/>
+          <a:lstStyle/>
+          <a:p>
+            <a:pPr indent="0" marL="0">
+              <a:buNone/>
+            </a:pPr>
+            <a:r>
+              <a:rPr lang="en-US" sz="1600" b="1" dirty="0">
+                <a:solidFill>
+                  <a:srgbClr val="ECECF3"/>
+                </a:solidFill>
+                <a:latin typeface="Calibri" pitchFamily="34" charset="0"/>
+                <a:ea typeface="Calibri" pitchFamily="34" charset="-122"/>
+                <a:cs typeface="Calibri" pitchFamily="34" charset="-120"/>
+              </a:rPr>
+              <a:t>⚠  Current limitations</a:t>
+            </a:r>
+            <a:endParaRPr lang="en-US" sz="1600" dirty="0"/>
+          </a:p>
+        </p:txBody>
+      </p:sp>
+      <p:sp>
+        <p:nvSpPr>
+          <p:cNvPr id="7" name="Text 5"/>
+          <p:cNvSpPr/>
+          <p:nvPr/>
+        </p:nvSpPr>
+        <p:spPr>
+          <a:xfrm>
+            <a:off x="1005840" y="2651760"/>
+            <a:ext cx="4526280" cy="3108960"/>
+          </a:xfrm>
+          <a:prstGeom prst="rect">
+            <a:avLst/>
+          </a:prstGeom>
+          <a:noFill/>
+          <a:ln/>
+        </p:spPr>
+        <p:txBody>
+          <a:bodyPr wrap="square" lIns="0" tIns="0" rIns="0" bIns="0" rtlCol="0" anchor="t"/>
+          <a:lstStyle/>
+          <a:p>
+            <a:pPr marL="342900" indent="-342900">
+              <a:spcAft>
+                <a:spcPts val="1100"/>
+              </a:spcAft>
+              <a:buSzPct val="100000"/>
+              <a:buChar char="•"/>
+            </a:pPr>
+            <a:r>
+              <a:rPr lang="en-US" sz="1350" dirty="0">
+                <a:solidFill>
+                  <a:srgbClr val="9AA0B4"/>
+                </a:solidFill>
+                <a:latin typeface="Calibri" pitchFamily="34" charset="0"/>
+                <a:ea typeface="Calibri" pitchFamily="34" charset="-122"/>
+                <a:cs typeface="Calibri" pitchFamily="34" charset="-120"/>
+              </a:rPr>
+              <a:t>No user accounts — the app is stateless</a:t>
+            </a:r>
+            <a:endParaRPr lang="en-US" sz="1350" dirty="0"/>
+          </a:p>
+          <a:p>
+            <a:pPr marL="342900" indent="-342900">
+              <a:spcAft>
+                <a:spcPts val="1100"/>
+              </a:spcAft>
+              <a:buSzPct val="100000"/>
+              <a:buChar char="•"/>
+            </a:pPr>
+            <a:r>
+              <a:rPr lang="en-US" sz="1350" dirty="0">
+                <a:solidFill>
+                  <a:srgbClr val="9AA0B4"/>
+                </a:solidFill>
+                <a:latin typeface="Calibri" pitchFamily="34" charset="0"/>
+                <a:ea typeface="Calibri" pitchFamily="34" charset="-122"/>
+                <a:cs typeface="Calibri" pitchFamily="34" charset="-120"/>
+              </a:rPr>
+              <a:t>Recommends only from the 55-title curated library</a:t>
+            </a:r>
+            <a:endParaRPr lang="en-US" sz="1350" dirty="0"/>
+          </a:p>
+          <a:p>
+            <a:pPr marL="342900" indent="-342900">
+              <a:spcAft>
+                <a:spcPts val="1100"/>
+              </a:spcAft>
+              <a:buSzPct val="100000"/>
+              <a:buChar char="•"/>
+            </a:pPr>
+            <a:r>
+              <a:rPr lang="en-US" sz="1350" dirty="0">
+                <a:solidFill>
+                  <a:srgbClr val="9AA0B4"/>
+                </a:solidFill>
+                <a:latin typeface="Calibri" pitchFamily="34" charset="0"/>
+                <a:ea typeface="Calibri" pitchFamily="34" charset="-122"/>
+                <a:cs typeface="Calibri" pitchFamily="34" charset="-120"/>
+              </a:rPr>
+              <a:t>Runs locally — not yet deployed publicly</a:t>
+            </a:r>
+            <a:endParaRPr lang="en-US" sz="1350" dirty="0"/>
+          </a:p>
+          <a:p>
+            <a:pPr marL="342900" indent="-342900">
+              <a:buSzPct val="100000"/>
+              <a:buChar char="•"/>
+            </a:pPr>
+            <a:r>
+              <a:rPr lang="en-US" sz="1350" dirty="0">
+                <a:solidFill>
+                  <a:srgbClr val="9AA0B4"/>
+                </a:solidFill>
+                <a:latin typeface="Calibri" pitchFamily="34" charset="0"/>
+                <a:ea typeface="Calibri" pitchFamily="34" charset="-122"/>
+                <a:cs typeface="Calibri" pitchFamily="34" charset="-120"/>
+              </a:rPr>
+              <a:t>Free AI models can be slow or rate-limited</a:t>
+            </a:r>
+            <a:endParaRPr lang="en-US" sz="1350" dirty="0"/>
+          </a:p>
+        </p:txBody>
+      </p:sp>
+      <p:sp>
+        <p:nvSpPr>
+          <p:cNvPr id="8" name="Shape 6"/>
+          <p:cNvSpPr/>
+          <p:nvPr/>
+        </p:nvSpPr>
+        <p:spPr>
+          <a:xfrm>
+            <a:off x="6309360" y="1828800"/>
+            <a:ext cx="5212080" cy="4114800"/>
+          </a:xfrm>
+          <a:prstGeom prst="roundRect">
+            <a:avLst>
+              <a:gd name="adj" fmla="val 1778"/>
+            </a:avLst>
+          </a:prstGeom>
+          <a:solidFill>
+            <a:srgbClr val="1A1D27"/>
+          </a:solidFill>
+          <a:ln w="12700">
+            <a:solidFill>
+              <a:srgbClr val="2A2F3E"/>
+            </a:solidFill>
+            <a:prstDash val="solid"/>
+          </a:ln>
+          <a:effectLst>
+            <a:outerShdw sx="100000" sy="100000" kx="0" ky="0" algn="bl" rotWithShape="0" blurRad="101600" dist="38100" dir="8100000">
+              <a:srgbClr val="000000">
+                <a:alpha val="35000"/>
+              </a:srgbClr>
+            </a:outerShdw>
+          </a:effectLst>
+        </p:spPr>
+      </p:sp>
+      <p:sp>
+        <p:nvSpPr>
+          <p:cNvPr id="9" name="Text 7"/>
+          <p:cNvSpPr/>
+          <p:nvPr/>
+        </p:nvSpPr>
+        <p:spPr>
+          <a:xfrm>
+            <a:off x="6629400" y="2057400"/>
+            <a:ext cx="4572000" cy="365760"/>
+          </a:xfrm>
+          <a:prstGeom prst="rect">
+            <a:avLst/>
+          </a:prstGeom>
+          <a:noFill/>
+          <a:ln/>
+        </p:spPr>
+        <p:txBody>
+          <a:bodyPr wrap="square" lIns="0" tIns="0" rIns="0" bIns="0" rtlCol="0" anchor="ctr"/>
+          <a:lstStyle/>
+          <a:p>
+            <a:pPr indent="0" marL="0">
+              <a:buNone/>
+            </a:pPr>
+            <a:r>
+              <a:rPr lang="en-US" sz="1600" b="1" dirty="0">
+                <a:solidFill>
+                  <a:srgbClr val="FFB347"/>
+                </a:solidFill>
+                <a:latin typeface="Calibri" pitchFamily="34" charset="0"/>
+                <a:ea typeface="Calibri" pitchFamily="34" charset="-122"/>
+                <a:cs typeface="Calibri" pitchFamily="34" charset="-120"/>
+              </a:rPr>
+              <a:t>🚀  Future work</a:t>
+            </a:r>
+            <a:endParaRPr lang="en-US" sz="1600" dirty="0"/>
+          </a:p>
+        </p:txBody>
+      </p:sp>
+      <p:sp>
+        <p:nvSpPr>
+          <p:cNvPr id="10" name="Text 8"/>
+          <p:cNvSpPr/>
+          <p:nvPr/>
+        </p:nvSpPr>
+        <p:spPr>
+          <a:xfrm>
+            <a:off x="6675120" y="2651760"/>
+            <a:ext cx="4526280" cy="3108960"/>
+          </a:xfrm>
+          <a:prstGeom prst="rect">
+            <a:avLst/>
+          </a:prstGeom>
+          <a:noFill/>
+          <a:ln/>
+        </p:spPr>
+        <p:txBody>
+          <a:bodyPr wrap="square" lIns="0" tIns="0" rIns="0" bIns="0" rtlCol="0" anchor="t"/>
+          <a:lstStyle/>
+          <a:p>
+            <a:pPr indent="0" marL="0">
+              <a:buNone/>
+            </a:pPr>
+            <a:r>
+              <a:rPr lang="en-US" sz="1350" b="1" dirty="0">
+                <a:solidFill>
+                  <a:srgbClr val="FFB347"/>
+                </a:solidFill>
+                <a:latin typeface="Calibri" pitchFamily="34" charset="0"/>
+                <a:ea typeface="Calibri" pitchFamily="34" charset="-122"/>
+                <a:cs typeface="Calibri" pitchFamily="34" charset="-120"/>
+              </a:rPr>
+              <a:t>1.  </a:t>
+            </a:r>
+            <a:pPr indent="0" marL="0">
+              <a:spcAft>
+                <a:spcPts val="1300"/>
+              </a:spcAft>
+              <a:buNone/>
+            </a:pPr>
+            <a:r>
+              <a:rPr lang="en-US" sz="1350" dirty="0">
+                <a:solidFill>
+                  <a:srgbClr val="ECECF3"/>
+                </a:solidFill>
+                <a:latin typeface="Calibri" pitchFamily="34" charset="0"/>
+                <a:ea typeface="Calibri" pitchFamily="34" charset="-122"/>
+                <a:cs typeface="Calibri" pitchFamily="34" charset="-120"/>
+              </a:rPr>
+              <a:t>User profiles &amp; saved watch history</a:t>
+            </a:r>
+            <a:endParaRPr lang="en-US" sz="1350" dirty="0"/>
+          </a:p>
+          <a:p>
+            <a:pPr indent="0" marL="0">
+              <a:buNone/>
+            </a:pPr>
+            <a:r>
+              <a:rPr lang="en-US" sz="1350" b="1" dirty="0">
+                <a:solidFill>
+                  <a:srgbClr val="FFB347"/>
+                </a:solidFill>
+                <a:latin typeface="Calibri" pitchFamily="34" charset="0"/>
+                <a:ea typeface="Calibri" pitchFamily="34" charset="-122"/>
+                <a:cs typeface="Calibri" pitchFamily="34" charset="-120"/>
+              </a:rPr>
+              <a:t>2.  </a:t>
+            </a:r>
+            <a:pPr indent="0" marL="0">
+              <a:spcAft>
+                <a:spcPts val="1300"/>
+              </a:spcAft>
+              <a:buNone/>
+            </a:pPr>
+            <a:r>
+              <a:rPr lang="en-US" sz="1350" dirty="0">
+                <a:solidFill>
+                  <a:srgbClr val="ECECF3"/>
+                </a:solidFill>
+                <a:latin typeface="Calibri" pitchFamily="34" charset="0"/>
+                <a:ea typeface="Calibri" pitchFamily="34" charset="-122"/>
+                <a:cs typeface="Calibri" pitchFamily="34" charset="-120"/>
+              </a:rPr>
+              <a:t>Personalization that learns from your feedback</a:t>
+            </a:r>
+            <a:endParaRPr lang="en-US" sz="1350" dirty="0"/>
+          </a:p>
+          <a:p>
+            <a:pPr indent="0" marL="0">
+              <a:buNone/>
+            </a:pPr>
+            <a:r>
+              <a:rPr lang="en-US" sz="1350" b="1" dirty="0">
+                <a:solidFill>
+                  <a:srgbClr val="FFB347"/>
+                </a:solidFill>
+                <a:latin typeface="Calibri" pitchFamily="34" charset="0"/>
+                <a:ea typeface="Calibri" pitchFamily="34" charset="-122"/>
+                <a:cs typeface="Calibri" pitchFamily="34" charset="-120"/>
+              </a:rPr>
+              <a:t>3.  </a:t>
+            </a:r>
+            <a:pPr indent="0" marL="0">
+              <a:spcAft>
+                <a:spcPts val="1300"/>
+              </a:spcAft>
+              <a:buNone/>
+            </a:pPr>
+            <a:r>
+              <a:rPr lang="en-US" sz="1350" dirty="0">
+                <a:solidFill>
+                  <a:srgbClr val="ECECF3"/>
+                </a:solidFill>
+                <a:latin typeface="Calibri" pitchFamily="34" charset="0"/>
+                <a:ea typeface="Calibri" pitchFamily="34" charset="-122"/>
+                <a:cs typeface="Calibri" pitchFamily="34" charset="-120"/>
+              </a:rPr>
+              <a:t>Larger library — recommend from TMDB &amp; RAWG directly</a:t>
+            </a:r>
+            <a:endParaRPr lang="en-US" sz="1350" dirty="0"/>
+          </a:p>
+          <a:p>
+            <a:pPr indent="0" marL="0">
+              <a:buNone/>
+            </a:pPr>
+            <a:r>
+              <a:rPr lang="en-US" sz="1350" b="1" dirty="0">
+                <a:solidFill>
+                  <a:srgbClr val="FFB347"/>
+                </a:solidFill>
+                <a:latin typeface="Calibri" pitchFamily="34" charset="0"/>
+                <a:ea typeface="Calibri" pitchFamily="34" charset="-122"/>
+                <a:cs typeface="Calibri" pitchFamily="34" charset="-120"/>
+              </a:rPr>
+              <a:t>4.  </a:t>
+            </a:r>
+            <a:pPr indent="0" marL="0">
+              <a:spcAft>
+                <a:spcPts val="1300"/>
+              </a:spcAft>
+              <a:buNone/>
+            </a:pPr>
+            <a:r>
+              <a:rPr lang="en-US" sz="1350" dirty="0">
+                <a:solidFill>
+                  <a:srgbClr val="ECECF3"/>
+                </a:solidFill>
+                <a:latin typeface="Calibri" pitchFamily="34" charset="0"/>
+                <a:ea typeface="Calibri" pitchFamily="34" charset="-122"/>
+                <a:cs typeface="Calibri" pitchFamily="34" charset="-120"/>
+              </a:rPr>
+              <a:t>Deployment: web hosting + database integration</a:t>
+            </a:r>
+            <a:endParaRPr lang="en-US" sz="1350" dirty="0"/>
+          </a:p>
+          <a:p>
+            <a:pPr indent="0" marL="0">
+              <a:buNone/>
+            </a:pPr>
+            <a:r>
+              <a:rPr lang="en-US" sz="1350" b="1" dirty="0">
+                <a:solidFill>
+                  <a:srgbClr val="FFB347"/>
+                </a:solidFill>
+                <a:latin typeface="Calibri" pitchFamily="34" charset="0"/>
+                <a:ea typeface="Calibri" pitchFamily="34" charset="-122"/>
+                <a:cs typeface="Calibri" pitchFamily="34" charset="-120"/>
+              </a:rPr>
+              <a:t>5.  </a:t>
+            </a:r>
+            <a:pPr indent="0" marL="0">
+              <a:spcAft>
+                <a:spcPts val="1300"/>
+              </a:spcAft>
+              <a:buNone/>
+            </a:pPr>
+            <a:r>
+              <a:rPr lang="en-US" sz="1350" dirty="0">
+                <a:solidFill>
+                  <a:srgbClr val="ECECF3"/>
+                </a:solidFill>
+                <a:latin typeface="Calibri" pitchFamily="34" charset="0"/>
+                <a:ea typeface="Calibri" pitchFamily="34" charset="-122"/>
+                <a:cs typeface="Calibri" pitchFamily="34" charset="-120"/>
+              </a:rPr>
+              <a:t>Automated tests (TDD) for the domain layer</a:t>
+            </a:r>
+            <a:endParaRPr lang="en-US" sz="1350" dirty="0"/>
+          </a:p>
+        </p:txBody>
+      </p:sp>
+      <p:sp>
+        <p:nvSpPr>
+          <p:cNvPr id="11" name="Text 9"/>
+          <p:cNvSpPr/>
+          <p:nvPr/>
+        </p:nvSpPr>
+        <p:spPr>
+          <a:xfrm>
+            <a:off x="640080" y="6400800"/>
+            <a:ext cx="8229600" cy="274320"/>
+          </a:xfrm>
+          <a:prstGeom prst="rect">
+            <a:avLst/>
+          </a:prstGeom>
+          <a:noFill/>
+          <a:ln/>
+        </p:spPr>
+        <p:txBody>
+          <a:bodyPr wrap="square" lIns="0" tIns="0" rIns="0" bIns="0" rtlCol="0" anchor="ctr"/>
+          <a:lstStyle/>
+          <a:p>
+            <a:pPr indent="0" marL="0">
+              <a:buNone/>
+            </a:pPr>
+            <a:r>
+              <a:rPr lang="en-US" sz="900" b="1" dirty="0">
+                <a:solidFill>
+                  <a:srgbClr val="FFB347"/>
+                </a:solidFill>
+                <a:latin typeface="Calibri" pitchFamily="34" charset="0"/>
+                <a:ea typeface="Calibri" pitchFamily="34" charset="-122"/>
+                <a:cs typeface="Calibri" pitchFamily="34" charset="-120"/>
+              </a:rPr>
+              <a:t>CINEMATCH</a:t>
+            </a:r>
+            <a:pPr indent="0" marL="0">
+              <a:buNone/>
+            </a:pPr>
+            <a:r>
+              <a:rPr lang="en-US" sz="900" dirty="0">
+                <a:solidFill>
+                  <a:srgbClr val="9AA0B4"/>
+                </a:solidFill>
+                <a:latin typeface="Calibri" pitchFamily="34" charset="0"/>
+                <a:ea typeface="Calibri" pitchFamily="34" charset="-122"/>
+                <a:cs typeface="Calibri" pitchFamily="34" charset="-120"/>
+              </a:rPr>
+              <a:t>   ·   AI-Powered Movie &amp; Game Recommender</a:t>
+            </a:r>
+            <a:endParaRPr lang="en-US" sz="900" dirty="0"/>
+          </a:p>
+        </p:txBody>
+      </p:sp>
+      <p:sp>
+        <p:nvSpPr>
+          <p:cNvPr id="12" name="Text 10"/>
+          <p:cNvSpPr/>
+          <p:nvPr/>
+        </p:nvSpPr>
+        <p:spPr>
+          <a:xfrm>
+            <a:off x="11064240" y="6400800"/>
+            <a:ext cx="457200" cy="274320"/>
+          </a:xfrm>
+          <a:prstGeom prst="rect">
+            <a:avLst/>
+          </a:prstGeom>
+          <a:noFill/>
+          <a:ln/>
+        </p:spPr>
+        <p:txBody>
+          <a:bodyPr wrap="square" lIns="0" tIns="0" rIns="0" bIns="0" rtlCol="0" anchor="ctr"/>
+          <a:lstStyle/>
+          <a:p>
+            <a:pPr algn="r" indent="0" marL="0">
+              <a:buNone/>
+            </a:pPr>
+            <a:r>
+              <a:rPr lang="en-US" sz="900" dirty="0">
+                <a:solidFill>
+                  <a:srgbClr val="9AA0B4"/>
+                </a:solidFill>
+                <a:latin typeface="Calibri" pitchFamily="34" charset="0"/>
+                <a:ea typeface="Calibri" pitchFamily="34" charset="-122"/>
+                <a:cs typeface="Calibri" pitchFamily="34" charset="-120"/>
+              </a:rPr>
+              <a:t>16</a:t>
+            </a:r>
+            <a:endParaRPr lang="en-US" sz="900" dirty="0"/>
+          </a:p>
+        </p:txBody>
+      </p:sp>
+    </p:spTree>
+  </p:cSld>
+  <p:clrMapOvr>
+    <a:masterClrMapping/>
+  </p:clrMapOvr>
+</p:sld>
+</file>
+
+<file path=ppt/slides/slide17.xml><?xml version="1.0" encoding="utf-8"?>
+<p:sld xmlns:a="http://schemas.openxmlformats.org/drawingml/2006/main" xmlns:r="http://schemas.openxmlformats.org/officeDocument/2006/relationships" xmlns:p="http://schemas.openxmlformats.org/presentationml/2006/main">
+  <p:cSld name="Slide 17">
     <p:bg>
       <p:bgPr>
         <a:solidFill>

</xml_diff>

<commit_message>
Remove all name placeholders from title slide
Title slide now shows only: CINEMATCH title, tagline, course info.
No member numbers, no name fields.

Co-Authored-By: Claude Sonnet 4.6 <noreply@anthropic.com>
</commit_message>
<xml_diff>
--- a/deliverables/CINEMATCH-Presentation.pptx
+++ b/deliverables/CINEMATCH-Presentation.pptx
@@ -2451,240 +2451,6 @@
         </p:nvSpPr>
         <p:spPr>
           <a:xfrm>
-            <a:off x="3474720" y="4160520"/>
-            <a:ext cx="2560320" cy="329184"/>
-          </a:xfrm>
-          <a:prstGeom prst="rect">
-            <a:avLst/>
-          </a:prstGeom>
-          <a:noFill/>
-          <a:ln/>
-        </p:spPr>
-        <p:txBody>
-          <a:bodyPr wrap="square" lIns="0" tIns="0" rIns="0" bIns="0" rtlCol="0" anchor="ctr"/>
-          <a:lstStyle/>
-          <a:p>
-            <a:pPr algn="ctr" indent="0" marL="0">
-              <a:buNone/>
-            </a:pPr>
-            <a:r>
-              <a:rPr lang="en-US" sz="1300" dirty="0">
-                <a:solidFill>
-                  <a:srgbClr val="ECECF3"/>
-                </a:solidFill>
-                <a:latin typeface="Calibri" pitchFamily="34" charset="0"/>
-                <a:ea typeface="Calibri" pitchFamily="34" charset="-122"/>
-                <a:cs typeface="Calibri" pitchFamily="34" charset="-120"/>
-              </a:rPr>
-              <a:t>[Name]</a:t>
-            </a:r>
-            <a:endParaRPr lang="en-US" sz="1300" dirty="0"/>
-          </a:p>
-        </p:txBody>
-      </p:sp>
-      <p:sp>
-        <p:nvSpPr>
-          <p:cNvPr id="7" name="Text 5"/>
-          <p:cNvSpPr/>
-          <p:nvPr/>
-        </p:nvSpPr>
-        <p:spPr>
-          <a:xfrm>
-            <a:off x="6400800" y="4160520"/>
-            <a:ext cx="2560320" cy="329184"/>
-          </a:xfrm>
-          <a:prstGeom prst="rect">
-            <a:avLst/>
-          </a:prstGeom>
-          <a:noFill/>
-          <a:ln/>
-        </p:spPr>
-        <p:txBody>
-          <a:bodyPr wrap="square" lIns="0" tIns="0" rIns="0" bIns="0" rtlCol="0" anchor="ctr"/>
-          <a:lstStyle/>
-          <a:p>
-            <a:pPr algn="ctr" indent="0" marL="0">
-              <a:buNone/>
-            </a:pPr>
-            <a:r>
-              <a:rPr lang="en-US" sz="1300" dirty="0">
-                <a:solidFill>
-                  <a:srgbClr val="ECECF3"/>
-                </a:solidFill>
-                <a:latin typeface="Calibri" pitchFamily="34" charset="0"/>
-                <a:ea typeface="Calibri" pitchFamily="34" charset="-122"/>
-                <a:cs typeface="Calibri" pitchFamily="34" charset="-120"/>
-              </a:rPr>
-              <a:t>[Name]</a:t>
-            </a:r>
-            <a:endParaRPr lang="en-US" sz="1300" dirty="0"/>
-          </a:p>
-        </p:txBody>
-      </p:sp>
-      <p:sp>
-        <p:nvSpPr>
-          <p:cNvPr id="8" name="Text 6"/>
-          <p:cNvSpPr/>
-          <p:nvPr/>
-        </p:nvSpPr>
-        <p:spPr>
-          <a:xfrm>
-            <a:off x="3474720" y="4544568"/>
-            <a:ext cx="2560320" cy="329184"/>
-          </a:xfrm>
-          <a:prstGeom prst="rect">
-            <a:avLst/>
-          </a:prstGeom>
-          <a:noFill/>
-          <a:ln/>
-        </p:spPr>
-        <p:txBody>
-          <a:bodyPr wrap="square" lIns="0" tIns="0" rIns="0" bIns="0" rtlCol="0" anchor="ctr"/>
-          <a:lstStyle/>
-          <a:p>
-            <a:pPr algn="ctr" indent="0" marL="0">
-              <a:buNone/>
-            </a:pPr>
-            <a:r>
-              <a:rPr lang="en-US" sz="1300" dirty="0">
-                <a:solidFill>
-                  <a:srgbClr val="ECECF3"/>
-                </a:solidFill>
-                <a:latin typeface="Calibri" pitchFamily="34" charset="0"/>
-                <a:ea typeface="Calibri" pitchFamily="34" charset="-122"/>
-                <a:cs typeface="Calibri" pitchFamily="34" charset="-120"/>
-              </a:rPr>
-              <a:t>[Name]</a:t>
-            </a:r>
-            <a:endParaRPr lang="en-US" sz="1300" dirty="0"/>
-          </a:p>
-        </p:txBody>
-      </p:sp>
-      <p:sp>
-        <p:nvSpPr>
-          <p:cNvPr id="9" name="Text 7"/>
-          <p:cNvSpPr/>
-          <p:nvPr/>
-        </p:nvSpPr>
-        <p:spPr>
-          <a:xfrm>
-            <a:off x="6400800" y="4544568"/>
-            <a:ext cx="2560320" cy="329184"/>
-          </a:xfrm>
-          <a:prstGeom prst="rect">
-            <a:avLst/>
-          </a:prstGeom>
-          <a:noFill/>
-          <a:ln/>
-        </p:spPr>
-        <p:txBody>
-          <a:bodyPr wrap="square" lIns="0" tIns="0" rIns="0" bIns="0" rtlCol="0" anchor="ctr"/>
-          <a:lstStyle/>
-          <a:p>
-            <a:pPr algn="ctr" indent="0" marL="0">
-              <a:buNone/>
-            </a:pPr>
-            <a:r>
-              <a:rPr lang="en-US" sz="1300" dirty="0">
-                <a:solidFill>
-                  <a:srgbClr val="ECECF3"/>
-                </a:solidFill>
-                <a:latin typeface="Calibri" pitchFamily="34" charset="0"/>
-                <a:ea typeface="Calibri" pitchFamily="34" charset="-122"/>
-                <a:cs typeface="Calibri" pitchFamily="34" charset="-120"/>
-              </a:rPr>
-              <a:t>[Name]</a:t>
-            </a:r>
-            <a:endParaRPr lang="en-US" sz="1300" dirty="0"/>
-          </a:p>
-        </p:txBody>
-      </p:sp>
-      <p:sp>
-        <p:nvSpPr>
-          <p:cNvPr id="10" name="Text 8"/>
-          <p:cNvSpPr/>
-          <p:nvPr/>
-        </p:nvSpPr>
-        <p:spPr>
-          <a:xfrm>
-            <a:off x="3474720" y="4928616"/>
-            <a:ext cx="2560320" cy="329184"/>
-          </a:xfrm>
-          <a:prstGeom prst="rect">
-            <a:avLst/>
-          </a:prstGeom>
-          <a:noFill/>
-          <a:ln/>
-        </p:spPr>
-        <p:txBody>
-          <a:bodyPr wrap="square" lIns="0" tIns="0" rIns="0" bIns="0" rtlCol="0" anchor="ctr"/>
-          <a:lstStyle/>
-          <a:p>
-            <a:pPr algn="ctr" indent="0" marL="0">
-              <a:buNone/>
-            </a:pPr>
-            <a:r>
-              <a:rPr lang="en-US" sz="1300" dirty="0">
-                <a:solidFill>
-                  <a:srgbClr val="ECECF3"/>
-                </a:solidFill>
-                <a:latin typeface="Calibri" pitchFamily="34" charset="0"/>
-                <a:ea typeface="Calibri" pitchFamily="34" charset="-122"/>
-                <a:cs typeface="Calibri" pitchFamily="34" charset="-120"/>
-              </a:rPr>
-              <a:t>[Name]</a:t>
-            </a:r>
-            <a:endParaRPr lang="en-US" sz="1300" dirty="0"/>
-          </a:p>
-        </p:txBody>
-      </p:sp>
-      <p:sp>
-        <p:nvSpPr>
-          <p:cNvPr id="11" name="Text 9"/>
-          <p:cNvSpPr/>
-          <p:nvPr/>
-        </p:nvSpPr>
-        <p:spPr>
-          <a:xfrm>
-            <a:off x="6400800" y="4928616"/>
-            <a:ext cx="2560320" cy="329184"/>
-          </a:xfrm>
-          <a:prstGeom prst="rect">
-            <a:avLst/>
-          </a:prstGeom>
-          <a:noFill/>
-          <a:ln/>
-        </p:spPr>
-        <p:txBody>
-          <a:bodyPr wrap="square" lIns="0" tIns="0" rIns="0" bIns="0" rtlCol="0" anchor="ctr"/>
-          <a:lstStyle/>
-          <a:p>
-            <a:pPr algn="ctr" indent="0" marL="0">
-              <a:buNone/>
-            </a:pPr>
-            <a:r>
-              <a:rPr lang="en-US" sz="1300" dirty="0">
-                <a:solidFill>
-                  <a:srgbClr val="ECECF3"/>
-                </a:solidFill>
-                <a:latin typeface="Calibri" pitchFamily="34" charset="0"/>
-                <a:ea typeface="Calibri" pitchFamily="34" charset="-122"/>
-                <a:cs typeface="Calibri" pitchFamily="34" charset="-120"/>
-              </a:rPr>
-              <a:t>[Name]</a:t>
-            </a:r>
-            <a:endParaRPr lang="en-US" sz="1300" dirty="0"/>
-          </a:p>
-        </p:txBody>
-      </p:sp>
-      <p:sp>
-        <p:nvSpPr>
-          <p:cNvPr id="12" name="Text 10"/>
-          <p:cNvSpPr/>
-          <p:nvPr/>
-        </p:nvSpPr>
-        <p:spPr>
-          <a:xfrm>
             <a:off x="640080" y="6400800"/>
             <a:ext cx="8229600" cy="274320"/>
           </a:xfrm>
@@ -2732,7 +2498,7 @@
       </p:sp>
       <p:sp>
         <p:nvSpPr>
-          <p:cNvPr id="13" name="Text 11"/>
+          <p:cNvPr id="7" name="Text 5"/>
           <p:cNvSpPr/>
           <p:nvPr/>
         </p:nvSpPr>

</xml_diff>